<commit_message>
Harden deployment and refresh jury presentation
Co-authored-by: Copilot App <223556219+Copilot@users.noreply.github.com>
</commit_message>
<xml_diff>
--- a/presentation/SaaSsum_AI_Presentation.pptx
+++ b/presentation/SaaSsum_AI_Presentation.pptx
@@ -3134,7 +3134,7 @@
                 </a:solidFill>
                 <a:latin typeface="Aptos"/>
               </a:rPr>
-              <a:t>SaaSsum AI</a:t>
+              <a:t>tenantAI</a:t>
             </a:r>
           </a:p>
         </p:txBody>
@@ -3169,7 +3169,7 @@
                 </a:solidFill>
                 <a:latin typeface="Aptos"/>
               </a:rPr>
-              <a:t>Multi-tenant AI chatbot platform | Hackathon presentation</a:t>
+              <a:t>Secure multi-tenant AI chatbot platform | Jury presentation</a:t>
             </a:r>
           </a:p>
         </p:txBody>
@@ -3218,7 +3218,7 @@
         <p:spPr>
           <a:xfrm>
             <a:off x="777240" y="3063240"/>
-            <a:ext cx="9601200" cy="411480"/>
+            <a:ext cx="10241280" cy="411480"/>
           </a:xfrm>
           <a:prstGeom prst="rect">
             <a:avLst/>
@@ -3239,7 +3239,7 @@
                 </a:solidFill>
                 <a:latin typeface="Aptos"/>
               </a:rPr>
-              <a:t>Production direction: FastAPI + SQLAlchemy + Next.js + tenant-scoped RAG</a:t>
+              <a:t>FastAPI + SQLAlchemy + Next.js + tenant-scoped RAG + Telegram worker</a:t>
             </a:r>
           </a:p>
         </p:txBody>
@@ -3274,7 +3274,7 @@
                 </a:solidFill>
                 <a:latin typeface="Aptos"/>
               </a:rPr>
-              <a:t>Implemented surfaces are distinguished from follow-up integration work.</a:t>
+              <a:t>Verified locally with tenant isolation, seeded jury data, frontend build, and backend tests.</a:t>
             </a:r>
           </a:p>
         </p:txBody>
@@ -6335,7 +6335,7 @@
                 </a:solidFill>
                 <a:latin typeface="Aptos"/>
               </a:rPr>
-              <a:t>Live demo path</a:t>
+              <a:t>Live jury demo path</a:t>
             </a:r>
           </a:p>
         </p:txBody>
@@ -6370,7 +6370,7 @@
                 </a:solidFill>
                 <a:latin typeface="Aptos"/>
               </a:rPr>
-              <a:t>Use real data and label anything not yet deployed.</a:t>
+              <a:t>A concise, repeatable flow for proving value and isolation.</a:t>
             </a:r>
           </a:p>
         </p:txBody>
@@ -6524,7 +6524,7 @@
         <p:spPr>
           <a:xfrm>
             <a:off x="914400" y="4206240"/>
-            <a:ext cx="7680960" cy="457200"/>
+            <a:ext cx="9144000" cy="457200"/>
           </a:xfrm>
           <a:prstGeom prst="rect">
             <a:avLst/>
@@ -6545,7 +6545,7 @@
                 </a:solidFill>
                 <a:latin typeface="Aptos"/>
               </a:rPr>
-              <a:t>5  Register a second company and verify isolation</a:t>
+              <a:t>5  Inspect audit telemetry and run the cross-tenant denial demo</a:t>
             </a:r>
           </a:p>
         </p:txBody>
@@ -6558,7 +6558,7 @@
         </p:nvSpPr>
         <p:spPr>
           <a:xfrm>
-            <a:off x="914400" y="5715000"/>
+            <a:off x="914400" y="4846320"/>
             <a:ext cx="10058400" cy="320040"/>
           </a:xfrm>
           <a:prstGeom prst="rect">
@@ -6580,7 +6580,7 @@
                 </a:solidFill>
                 <a:latin typeface="Aptos"/>
               </a:rPr>
-              <a:t>Telegram bot: integration point documented; no fabricated bot or token.</a:t>
+              <a:t>6  Telegram: /login → /documents → /upload → /conversations → /audits</a:t>
             </a:r>
           </a:p>
         </p:txBody>
@@ -6676,7 +6676,7 @@
                 </a:solidFill>
                 <a:latin typeface="Aptos"/>
               </a:rPr>
-              <a:t>Prepare production infrastructure without performing paid or irreversible actions.</a:t>
+              <a:t>Production-minded configuration with an explicit operator checklist.</a:t>
             </a:r>
           </a:p>
         </p:txBody>
@@ -6756,7 +6756,7 @@
                 </a:solidFill>
                 <a:latin typeface="Aptos"/>
               </a:rPr>
-              <a:t>Runtime</a:t>
+              <a:t>Render architecture</a:t>
             </a:r>
           </a:p>
         </p:txBody>
@@ -6791,7 +6791,7 @@
                 </a:solidFill>
                 <a:latin typeface="Aptos"/>
               </a:rPr>
-              <a:t>Frontend and backend containers, managed PostgreSQL, persistent document storage, SMTP provider.</a:t>
+              <a:t>Managed PostgreSQL, FastAPI web service, Next.js web service, and a dedicated Telegram background worker.</a:t>
             </a:r>
           </a:p>
         </p:txBody>
@@ -6906,7 +6906,7 @@
                 </a:solidFill>
                 <a:latin typeface="Aptos"/>
               </a:rPr>
-              <a:t>19 existing backend tests pass, including tenant isolation, RAG citations, admin access, and uploads.</a:t>
+              <a:t>20 backend tests pass; frontend production build generates 16 routes; Telegram module compiles.</a:t>
             </a:r>
           </a:p>
         </p:txBody>
@@ -6986,7 +6986,7 @@
                 </a:solidFill>
                 <a:latin typeface="Aptos"/>
               </a:rPr>
-              <a:t>Operator checklist</a:t>
+              <a:t>Hardening</a:t>
             </a:r>
           </a:p>
         </p:txBody>
@@ -7021,7 +7021,7 @@
                 </a:solidFill>
                 <a:latin typeface="Aptos"/>
               </a:rPr>
-              <a:t>Set secrets, CORS, storage, health checks, migrations, and verify registration before launch.</a:t>
+              <a:t>Production reload disabled, strict environment-driven CORS, friendly upload errors, and cleanup of failed files.</a:t>
             </a:r>
           </a:p>
         </p:txBody>
@@ -7117,7 +7117,7 @@
                 </a:solidFill>
                 <a:latin typeface="Aptos"/>
               </a:rPr>
-              <a:t>Secure foundations first; integrate only what can be verified.</a:t>
+              <a:t>A secure foundation ready for a focused jury demonstration.</a:t>
             </a:r>
           </a:p>
         </p:txBody>
@@ -7197,7 +7197,7 @@
                 </a:solidFill>
                 <a:latin typeface="Aptos"/>
               </a:rPr>
-              <a:t>Now</a:t>
+              <a:t>Implemented</a:t>
             </a:r>
           </a:p>
         </p:txBody>
@@ -7232,7 +7232,7 @@
                 </a:solidFill>
                 <a:latin typeface="Aptos"/>
               </a:rPr>
-              <a:t>Tenant-scoped FastAPI APIs, grounded RAG, OTP registration, dark-first auth UI, audit telemetry.</a:t>
+              <a:t>OTP registration, tenant-scoped RAG, citations, audit telemetry, seeded jury data, accessible landing page, privacy and terms pages.</a:t>
             </a:r>
           </a:p>
         </p:txBody>
@@ -7312,7 +7312,7 @@
                 </a:solidFill>
                 <a:latin typeface="Aptos"/>
               </a:rPr>
-              <a:t>Next</a:t>
+              <a:t>Connected</a:t>
             </a:r>
           </a:p>
         </p:txBody>
@@ -7347,7 +7347,7 @@
                 </a:solidFill>
                 <a:latin typeface="Aptos"/>
               </a:rPr>
-              <a:t>Complete Telegram account linking and 120-second session enforcement on a shared bot service.</a:t>
+              <a:t>Telegram supports sliding inactivity sessions, chatbot questions, uploads, conversations, audits, and tenant-admin settings.</a:t>
             </a:r>
           </a:p>
         </p:txBody>
@@ -7427,7 +7427,7 @@
                 </a:solidFill>
                 <a:latin typeface="Aptos"/>
               </a:rPr>
-              <a:t>Future</a:t>
+              <a:t>Scale next</a:t>
             </a:r>
           </a:p>
         </p:txBody>
@@ -7462,7 +7462,7 @@
                 </a:solidFill>
                 <a:latin typeface="Aptos"/>
               </a:rPr>
-              <a:t>Async workers, OCR, object storage, richer feedback/export, and managed deployment verification.</a:t>
+              <a:t>Alembic migration history, object storage, async document workers, OCR, and production Render verification.</a:t>
             </a:r>
           </a:p>
         </p:txBody>

</xml_diff>

<commit_message>
Add detailed jury presentation slides
Co-authored-by: Copilot App <223556219+Copilot@users.noreply.github.com>
</commit_message>
<xml_diff>
--- a/presentation/SaaSsum_AI_Presentation.pptx
+++ b/presentation/SaaSsum_AI_Presentation.pptx
@@ -21,6 +21,13 @@
     <p:sldId id="269" r:id="rId20"/>
     <p:sldId id="270" r:id="rId21"/>
     <p:sldId id="271" r:id="rId22"/>
+    <p:sldId id="272" r:id="rId23"/>
+    <p:sldId id="273" r:id="rId24"/>
+    <p:sldId id="274" r:id="rId25"/>
+    <p:sldId id="275" r:id="rId26"/>
+    <p:sldId id="276" r:id="rId27"/>
+    <p:sldId id="277" r:id="rId28"/>
+    <p:sldId id="278" r:id="rId29"/>
   </p:sldIdLst>
   <p:sldSz cx="12191695" cy="6858000" type="screen4x3"/>
   <p:notesSz cx="6858000" cy="9144000"/>
@@ -6020,7 +6027,7 @@
                 </a:solidFill>
                 <a:latin typeface="Aptos"/>
               </a:rPr>
-              <a:t>Conclusion and roadmap</a:t>
+              <a:t>Data model and isolation boundary</a:t>
             </a:r>
           </a:p>
         </p:txBody>
@@ -6055,7 +6062,7 @@
                 </a:solidFill>
                 <a:latin typeface="Aptos"/>
               </a:rPr>
-              <a:t>Secure foundations first; integrate only what can be verified.</a:t>
+              <a:t>Tenant identity is carried through every relationship that contains private knowledge.</a:t>
             </a:r>
           </a:p>
         </p:txBody>
@@ -6068,8 +6075,8 @@
         </p:nvSpPr>
         <p:spPr>
           <a:xfrm>
-            <a:off x="685800" y="1645920"/>
-            <a:ext cx="3474720" cy="3291840"/>
+            <a:off x="502920" y="1554480"/>
+            <a:ext cx="2148840" cy="3611880"/>
           </a:xfrm>
           <a:prstGeom prst="roundRect">
             <a:avLst/>
@@ -6113,8 +6120,8 @@
         </p:nvSpPr>
         <p:spPr>
           <a:xfrm>
-            <a:off x="868680" y="1810512"/>
-            <a:ext cx="3108960" cy="320040"/>
+            <a:off x="685800" y="1719072"/>
+            <a:ext cx="1783080" cy="320040"/>
           </a:xfrm>
           <a:prstGeom prst="rect">
             <a:avLst/>
@@ -6135,7 +6142,7 @@
                 </a:solidFill>
                 <a:latin typeface="Aptos"/>
               </a:rPr>
-              <a:t>Now</a:t>
+              <a:t>Tenant</a:t>
             </a:r>
           </a:p>
         </p:txBody>
@@ -6148,8 +6155,8 @@
         </p:nvSpPr>
         <p:spPr>
           <a:xfrm>
-            <a:off x="868680" y="2240280"/>
-            <a:ext cx="3108960" cy="2560320"/>
+            <a:off x="685800" y="2148840"/>
+            <a:ext cx="1783080" cy="2880360"/>
           </a:xfrm>
           <a:prstGeom prst="rect">
             <a:avLst/>
@@ -6170,7 +6177,10 @@
                 </a:solidFill>
                 <a:latin typeface="Aptos"/>
               </a:rPr>
-              <a:t>Tenant-scoped FastAPI APIs, grounded RAG, OTP registration, dark-first auth UI, audit telemetry.</a:t>
+              <a:t>Company workspace
+Slug and quota
+Admin membership
+Owns all private records</a:t>
             </a:r>
           </a:p>
         </p:txBody>
@@ -6183,8 +6193,8 @@
         </p:nvSpPr>
         <p:spPr>
           <a:xfrm>
-            <a:off x="4389120" y="1645920"/>
-            <a:ext cx="3474720" cy="3291840"/>
+            <a:off x="2788920" y="1554480"/>
+            <a:ext cx="2148840" cy="3611880"/>
           </a:xfrm>
           <a:prstGeom prst="roundRect">
             <a:avLst/>
@@ -6228,8 +6238,8 @@
         </p:nvSpPr>
         <p:spPr>
           <a:xfrm>
-            <a:off x="4572000" y="1810512"/>
-            <a:ext cx="3108960" cy="320040"/>
+            <a:off x="2971800" y="1719072"/>
+            <a:ext cx="1783080" cy="320040"/>
           </a:xfrm>
           <a:prstGeom prst="rect">
             <a:avLst/>
@@ -6250,7 +6260,7 @@
                 </a:solidFill>
                 <a:latin typeface="Aptos"/>
               </a:rPr>
-              <a:t>Next</a:t>
+              <a:t>User</a:t>
             </a:r>
           </a:p>
         </p:txBody>
@@ -6263,8 +6273,8 @@
         </p:nvSpPr>
         <p:spPr>
           <a:xfrm>
-            <a:off x="4572000" y="2240280"/>
-            <a:ext cx="3108960" cy="2560320"/>
+            <a:off x="2971800" y="2148840"/>
+            <a:ext cx="1783080" cy="2880360"/>
           </a:xfrm>
           <a:prstGeom prst="rect">
             <a:avLst/>
@@ -6285,7 +6295,10 @@
                 </a:solidFill>
                 <a:latin typeface="Aptos"/>
               </a:rPr>
-              <a:t>Complete Telegram account linking and 120-second session enforcement on a shared bot service.</a:t>
+              <a:t>Email and password hash
+Verified status
+Role: admin/user
+Belongs to one tenant</a:t>
             </a:r>
           </a:p>
         </p:txBody>
@@ -6298,8 +6311,8 @@
         </p:nvSpPr>
         <p:spPr>
           <a:xfrm>
-            <a:off x="8092440" y="1645920"/>
-            <a:ext cx="3474720" cy="3291840"/>
+            <a:off x="5074920" y="1554480"/>
+            <a:ext cx="2148840" cy="3611880"/>
           </a:xfrm>
           <a:prstGeom prst="roundRect">
             <a:avLst/>
@@ -6343,7 +6356,1470 @@
         </p:nvSpPr>
         <p:spPr>
           <a:xfrm>
-            <a:off x="8275319" y="1810512"/>
+            <a:off x="5257800" y="1719072"/>
+            <a:ext cx="1783080" cy="320040"/>
+          </a:xfrm>
+          <a:prstGeom prst="rect">
+            <a:avLst/>
+          </a:prstGeom>
+          <a:noFill/>
+        </p:spPr>
+        <p:txBody>
+          <a:bodyPr wrap="square">
+            <a:spAutoFit/>
+          </a:bodyPr>
+          <a:lstStyle/>
+          <a:p>
+            <a:pPr algn="l"/>
+            <a:r>
+              <a:rPr sz="1600" b="1">
+                <a:solidFill>
+                  <a:srgbClr val="2DD4BF"/>
+                </a:solidFill>
+                <a:latin typeface="Aptos"/>
+              </a:rPr>
+              <a:t>Document</a:t>
+            </a:r>
+          </a:p>
+        </p:txBody>
+      </p:sp>
+      <p:sp>
+        <p:nvSpPr>
+          <p:cNvPr id="12" name="TextBox 11"/>
+          <p:cNvSpPr txBox="1"/>
+          <p:nvPr/>
+        </p:nvSpPr>
+        <p:spPr>
+          <a:xfrm>
+            <a:off x="5257800" y="2148840"/>
+            <a:ext cx="1783080" cy="2880360"/>
+          </a:xfrm>
+          <a:prstGeom prst="rect">
+            <a:avLst/>
+          </a:prstGeom>
+          <a:noFill/>
+        </p:spPr>
+        <p:txBody>
+          <a:bodyPr wrap="square">
+            <a:spAutoFit/>
+          </a:bodyPr>
+          <a:lstStyle/>
+          <a:p>
+            <a:pPr algn="l"/>
+            <a:r>
+              <a:rPr sz="1200" b="0">
+                <a:solidFill>
+                  <a:srgbClr val="E5EDF7"/>
+                </a:solidFill>
+                <a:latin typeface="Aptos"/>
+              </a:rPr>
+              <a:t>Tenant-owned file
+PENDING → READY
+Parser metadata
+Safe deletion boundary</a:t>
+            </a:r>
+          </a:p>
+        </p:txBody>
+      </p:sp>
+      <p:sp>
+        <p:nvSpPr>
+          <p:cNvPr id="13" name="Rounded Rectangle 12"/>
+          <p:cNvSpPr/>
+          <p:nvPr/>
+        </p:nvSpPr>
+        <p:spPr>
+          <a:xfrm>
+            <a:off x="7360920" y="1554480"/>
+            <a:ext cx="2148840" cy="3611880"/>
+          </a:xfrm>
+          <a:prstGeom prst="roundRect">
+            <a:avLst/>
+          </a:prstGeom>
+          <a:solidFill>
+            <a:srgbClr val="111A2D"/>
+          </a:solidFill>
+          <a:ln>
+            <a:solidFill>
+              <a:srgbClr val="2D3A52"/>
+            </a:solidFill>
+          </a:ln>
+        </p:spPr>
+        <p:style>
+          <a:lnRef idx="1">
+            <a:schemeClr val="accent1"/>
+          </a:lnRef>
+          <a:fillRef idx="3">
+            <a:schemeClr val="accent1"/>
+          </a:fillRef>
+          <a:effectRef idx="2">
+            <a:schemeClr val="accent1"/>
+          </a:effectRef>
+          <a:fontRef idx="minor">
+            <a:schemeClr val="lt1"/>
+          </a:fontRef>
+        </p:style>
+        <p:txBody>
+          <a:bodyPr rtlCol="0" anchor="ctr"/>
+          <a:lstStyle/>
+          <a:p>
+            <a:pPr algn="ctr"/>
+          </a:p>
+        </p:txBody>
+      </p:sp>
+      <p:sp>
+        <p:nvSpPr>
+          <p:cNvPr id="14" name="TextBox 13"/>
+          <p:cNvSpPr txBox="1"/>
+          <p:nvPr/>
+        </p:nvSpPr>
+        <p:spPr>
+          <a:xfrm>
+            <a:off x="7543800" y="1719072"/>
+            <a:ext cx="1783080" cy="320040"/>
+          </a:xfrm>
+          <a:prstGeom prst="rect">
+            <a:avLst/>
+          </a:prstGeom>
+          <a:noFill/>
+        </p:spPr>
+        <p:txBody>
+          <a:bodyPr wrap="square">
+            <a:spAutoFit/>
+          </a:bodyPr>
+          <a:lstStyle/>
+          <a:p>
+            <a:pPr algn="l"/>
+            <a:r>
+              <a:rPr sz="1600" b="1">
+                <a:solidFill>
+                  <a:srgbClr val="2DD4BF"/>
+                </a:solidFill>
+                <a:latin typeface="Aptos"/>
+              </a:rPr>
+              <a:t>Chunks</a:t>
+            </a:r>
+          </a:p>
+        </p:txBody>
+      </p:sp>
+      <p:sp>
+        <p:nvSpPr>
+          <p:cNvPr id="15" name="TextBox 14"/>
+          <p:cNvSpPr txBox="1"/>
+          <p:nvPr/>
+        </p:nvSpPr>
+        <p:spPr>
+          <a:xfrm>
+            <a:off x="7543800" y="2148840"/>
+            <a:ext cx="1783080" cy="2880360"/>
+          </a:xfrm>
+          <a:prstGeom prst="rect">
+            <a:avLst/>
+          </a:prstGeom>
+          <a:noFill/>
+        </p:spPr>
+        <p:txBody>
+          <a:bodyPr wrap="square">
+            <a:spAutoFit/>
+          </a:bodyPr>
+          <a:lstStyle/>
+          <a:p>
+            <a:pPr algn="l"/>
+            <a:r>
+              <a:rPr sz="1200" b="0">
+                <a:solidFill>
+                  <a:srgbClr val="E5EDF7"/>
+                </a:solidFill>
+                <a:latin typeface="Aptos"/>
+              </a:rPr>
+              <a:t>Text segments
+Embedding vectors
+Page/source metadata
+Tenant-scoped retrieval</a:t>
+            </a:r>
+          </a:p>
+        </p:txBody>
+      </p:sp>
+      <p:sp>
+        <p:nvSpPr>
+          <p:cNvPr id="16" name="Rounded Rectangle 15"/>
+          <p:cNvSpPr/>
+          <p:nvPr/>
+        </p:nvSpPr>
+        <p:spPr>
+          <a:xfrm>
+            <a:off x="9646920" y="1554480"/>
+            <a:ext cx="2148840" cy="3611880"/>
+          </a:xfrm>
+          <a:prstGeom prst="roundRect">
+            <a:avLst/>
+          </a:prstGeom>
+          <a:solidFill>
+            <a:srgbClr val="111A2D"/>
+          </a:solidFill>
+          <a:ln>
+            <a:solidFill>
+              <a:srgbClr val="2D3A52"/>
+            </a:solidFill>
+          </a:ln>
+        </p:spPr>
+        <p:style>
+          <a:lnRef idx="1">
+            <a:schemeClr val="accent1"/>
+          </a:lnRef>
+          <a:fillRef idx="3">
+            <a:schemeClr val="accent1"/>
+          </a:fillRef>
+          <a:effectRef idx="2">
+            <a:schemeClr val="accent1"/>
+          </a:effectRef>
+          <a:fontRef idx="minor">
+            <a:schemeClr val="lt1"/>
+          </a:fontRef>
+        </p:style>
+        <p:txBody>
+          <a:bodyPr rtlCol="0" anchor="ctr"/>
+          <a:lstStyle/>
+          <a:p>
+            <a:pPr algn="ctr"/>
+          </a:p>
+        </p:txBody>
+      </p:sp>
+      <p:sp>
+        <p:nvSpPr>
+          <p:cNvPr id="17" name="TextBox 16"/>
+          <p:cNvSpPr txBox="1"/>
+          <p:nvPr/>
+        </p:nvSpPr>
+        <p:spPr>
+          <a:xfrm>
+            <a:off x="9829800" y="1719072"/>
+            <a:ext cx="1783080" cy="320040"/>
+          </a:xfrm>
+          <a:prstGeom prst="rect">
+            <a:avLst/>
+          </a:prstGeom>
+          <a:noFill/>
+        </p:spPr>
+        <p:txBody>
+          <a:bodyPr wrap="square">
+            <a:spAutoFit/>
+          </a:bodyPr>
+          <a:lstStyle/>
+          <a:p>
+            <a:pPr algn="l"/>
+            <a:r>
+              <a:rPr sz="1600" b="1">
+                <a:solidFill>
+                  <a:srgbClr val="2DD4BF"/>
+                </a:solidFill>
+                <a:latin typeface="Aptos"/>
+              </a:rPr>
+              <a:t>Conversation</a:t>
+            </a:r>
+          </a:p>
+        </p:txBody>
+      </p:sp>
+      <p:sp>
+        <p:nvSpPr>
+          <p:cNvPr id="18" name="TextBox 17"/>
+          <p:cNvSpPr txBox="1"/>
+          <p:nvPr/>
+        </p:nvSpPr>
+        <p:spPr>
+          <a:xfrm>
+            <a:off x="9829800" y="2148840"/>
+            <a:ext cx="1783080" cy="2880360"/>
+          </a:xfrm>
+          <a:prstGeom prst="rect">
+            <a:avLst/>
+          </a:prstGeom>
+          <a:noFill/>
+        </p:spPr>
+        <p:txBody>
+          <a:bodyPr wrap="square">
+            <a:spAutoFit/>
+          </a:bodyPr>
+          <a:lstStyle/>
+          <a:p>
+            <a:pPr algn="l"/>
+            <a:r>
+              <a:rPr sz="1200" b="0">
+                <a:solidFill>
+                  <a:srgbClr val="E5EDF7"/>
+                </a:solidFill>
+                <a:latin typeface="Aptos"/>
+              </a:rPr>
+              <a:t>Tenant-owned thread
+Messages and citations
+Audit-linked question
+No cross-tenant joins</a:t>
+            </a:r>
+          </a:p>
+        </p:txBody>
+      </p:sp>
+      <p:sp>
+        <p:nvSpPr>
+          <p:cNvPr id="19" name="TextBox 18"/>
+          <p:cNvSpPr txBox="1"/>
+          <p:nvPr/>
+        </p:nvSpPr>
+        <p:spPr>
+          <a:xfrm>
+            <a:off x="777240" y="5623560"/>
+            <a:ext cx="10607040" cy="365760"/>
+          </a:xfrm>
+          <a:prstGeom prst="rect">
+            <a:avLst/>
+          </a:prstGeom>
+          <a:noFill/>
+        </p:spPr>
+        <p:txBody>
+          <a:bodyPr wrap="square">
+            <a:spAutoFit/>
+          </a:bodyPr>
+          <a:lstStyle/>
+          <a:p>
+            <a:pPr algn="ctr"/>
+            <a:r>
+              <a:rPr sz="1500" b="0">
+                <a:solidFill>
+                  <a:srgbClr val="2DD4BF"/>
+                </a:solidFill>
+                <a:latin typeface="Aptos"/>
+              </a:rPr>
+              <a:t>Security invariant: a valid resource ID is not sufficient; the authenticated tenant must also own the resource.</a:t>
+            </a:r>
+          </a:p>
+        </p:txBody>
+      </p:sp>
+    </p:spTree>
+  </p:cSld>
+  <p:clrMapOvr>
+    <a:masterClrMapping/>
+  </p:clrMapOvr>
+</p:sld>
+</file>
+
+<file path=ppt/slides/slide17.xml><?xml version="1.0" encoding="utf-8"?>
+<p:sld xmlns:a="http://schemas.openxmlformats.org/drawingml/2006/main" xmlns:p="http://schemas.openxmlformats.org/presentationml/2006/main" xmlns:r="http://schemas.openxmlformats.org/officeDocument/2006/relationships">
+  <p:cSld>
+    <p:bg>
+      <p:bgPr>
+        <a:solidFill>
+          <a:srgbClr val="0B1120"/>
+        </a:solidFill>
+        <a:effectLst/>
+      </p:bgPr>
+    </p:bg>
+    <p:spTree>
+      <p:nvGrpSpPr>
+        <p:cNvPr id="1" name=""/>
+        <p:cNvGrpSpPr/>
+        <p:nvPr/>
+      </p:nvGrpSpPr>
+      <p:grpSpPr/>
+      <p:sp>
+        <p:nvSpPr>
+          <p:cNvPr id="2" name="TextBox 1"/>
+          <p:cNvSpPr txBox="1"/>
+          <p:nvPr/>
+        </p:nvSpPr>
+        <p:spPr>
+          <a:xfrm>
+            <a:off x="594360" y="411480"/>
+            <a:ext cx="10972800" cy="502920"/>
+          </a:xfrm>
+          <a:prstGeom prst="rect">
+            <a:avLst/>
+          </a:prstGeom>
+          <a:noFill/>
+        </p:spPr>
+        <p:txBody>
+          <a:bodyPr wrap="square">
+            <a:spAutoFit/>
+          </a:bodyPr>
+          <a:lstStyle/>
+          <a:p>
+            <a:pPr algn="l"/>
+            <a:r>
+              <a:rPr sz="2800" b="1">
+                <a:solidFill>
+                  <a:srgbClr val="E5EDF7"/>
+                </a:solidFill>
+                <a:latin typeface="Aptos"/>
+              </a:rPr>
+              <a:t>Request security flow</a:t>
+            </a:r>
+          </a:p>
+        </p:txBody>
+      </p:sp>
+      <p:sp>
+        <p:nvSpPr>
+          <p:cNvPr id="3" name="TextBox 2"/>
+          <p:cNvSpPr txBox="1"/>
+          <p:nvPr/>
+        </p:nvSpPr>
+        <p:spPr>
+          <a:xfrm>
+            <a:off x="621792" y="987552"/>
+            <a:ext cx="10789920" cy="320040"/>
+          </a:xfrm>
+          <a:prstGeom prst="rect">
+            <a:avLst/>
+          </a:prstGeom>
+          <a:noFill/>
+        </p:spPr>
+        <p:txBody>
+          <a:bodyPr wrap="square">
+            <a:spAutoFit/>
+          </a:bodyPr>
+          <a:lstStyle/>
+          <a:p>
+            <a:pPr algn="l"/>
+            <a:r>
+              <a:rPr sz="1200" b="0">
+                <a:solidFill>
+                  <a:srgbClr val="94A3B8"/>
+                </a:solidFill>
+                <a:latin typeface="Aptos"/>
+              </a:rPr>
+              <a:t>A typical chat request is authorized before retrieval or generation.</a:t>
+            </a:r>
+          </a:p>
+        </p:txBody>
+      </p:sp>
+      <p:sp>
+        <p:nvSpPr>
+          <p:cNvPr id="4" name="Rounded Rectangle 3"/>
+          <p:cNvSpPr/>
+          <p:nvPr/>
+        </p:nvSpPr>
+        <p:spPr>
+          <a:xfrm>
+            <a:off x="411480" y="1920240"/>
+            <a:ext cx="1371600" cy="1508760"/>
+          </a:xfrm>
+          <a:prstGeom prst="roundRect">
+            <a:avLst/>
+          </a:prstGeom>
+          <a:solidFill>
+            <a:srgbClr val="111A2D"/>
+          </a:solidFill>
+          <a:ln>
+            <a:solidFill>
+              <a:srgbClr val="2D3A52"/>
+            </a:solidFill>
+          </a:ln>
+        </p:spPr>
+        <p:style>
+          <a:lnRef idx="1">
+            <a:schemeClr val="accent1"/>
+          </a:lnRef>
+          <a:fillRef idx="3">
+            <a:schemeClr val="accent1"/>
+          </a:fillRef>
+          <a:effectRef idx="2">
+            <a:schemeClr val="accent1"/>
+          </a:effectRef>
+          <a:fontRef idx="minor">
+            <a:schemeClr val="lt1"/>
+          </a:fontRef>
+        </p:style>
+        <p:txBody>
+          <a:bodyPr rtlCol="0" anchor="ctr"/>
+          <a:lstStyle/>
+          <a:p>
+            <a:pPr algn="ctr"/>
+          </a:p>
+        </p:txBody>
+      </p:sp>
+      <p:sp>
+        <p:nvSpPr>
+          <p:cNvPr id="5" name="TextBox 4"/>
+          <p:cNvSpPr txBox="1"/>
+          <p:nvPr/>
+        </p:nvSpPr>
+        <p:spPr>
+          <a:xfrm>
+            <a:off x="594360" y="2084832"/>
+            <a:ext cx="1005840" cy="320040"/>
+          </a:xfrm>
+          <a:prstGeom prst="rect">
+            <a:avLst/>
+          </a:prstGeom>
+          <a:noFill/>
+        </p:spPr>
+        <p:txBody>
+          <a:bodyPr wrap="square">
+            <a:spAutoFit/>
+          </a:bodyPr>
+          <a:lstStyle/>
+          <a:p>
+            <a:pPr algn="l"/>
+            <a:r>
+              <a:rPr sz="1600" b="1">
+                <a:solidFill>
+                  <a:srgbClr val="2DD4BF"/>
+                </a:solidFill>
+                <a:latin typeface="Aptos"/>
+              </a:rPr>
+              <a:t>1</a:t>
+            </a:r>
+          </a:p>
+        </p:txBody>
+      </p:sp>
+      <p:sp>
+        <p:nvSpPr>
+          <p:cNvPr id="6" name="TextBox 5"/>
+          <p:cNvSpPr txBox="1"/>
+          <p:nvPr/>
+        </p:nvSpPr>
+        <p:spPr>
+          <a:xfrm>
+            <a:off x="594360" y="2514600"/>
+            <a:ext cx="1005840" cy="777239"/>
+          </a:xfrm>
+          <a:prstGeom prst="rect">
+            <a:avLst/>
+          </a:prstGeom>
+          <a:noFill/>
+        </p:spPr>
+        <p:txBody>
+          <a:bodyPr wrap="square">
+            <a:spAutoFit/>
+          </a:bodyPr>
+          <a:lstStyle/>
+          <a:p>
+            <a:pPr algn="l"/>
+            <a:r>
+              <a:rPr sz="1200" b="0">
+                <a:solidFill>
+                  <a:srgbClr val="E5EDF7"/>
+                </a:solidFill>
+                <a:latin typeface="Aptos"/>
+              </a:rPr>
+              <a:t>JWT
+verified</a:t>
+            </a:r>
+          </a:p>
+        </p:txBody>
+      </p:sp>
+      <p:sp>
+        <p:nvSpPr>
+          <p:cNvPr id="7" name="Rounded Rectangle 6"/>
+          <p:cNvSpPr/>
+          <p:nvPr/>
+        </p:nvSpPr>
+        <p:spPr>
+          <a:xfrm>
+            <a:off x="2075688" y="1920240"/>
+            <a:ext cx="1371600" cy="1508760"/>
+          </a:xfrm>
+          <a:prstGeom prst="roundRect">
+            <a:avLst/>
+          </a:prstGeom>
+          <a:solidFill>
+            <a:srgbClr val="111A2D"/>
+          </a:solidFill>
+          <a:ln>
+            <a:solidFill>
+              <a:srgbClr val="2D3A52"/>
+            </a:solidFill>
+          </a:ln>
+        </p:spPr>
+        <p:style>
+          <a:lnRef idx="1">
+            <a:schemeClr val="accent1"/>
+          </a:lnRef>
+          <a:fillRef idx="3">
+            <a:schemeClr val="accent1"/>
+          </a:fillRef>
+          <a:effectRef idx="2">
+            <a:schemeClr val="accent1"/>
+          </a:effectRef>
+          <a:fontRef idx="minor">
+            <a:schemeClr val="lt1"/>
+          </a:fontRef>
+        </p:style>
+        <p:txBody>
+          <a:bodyPr rtlCol="0" anchor="ctr"/>
+          <a:lstStyle/>
+          <a:p>
+            <a:pPr algn="ctr"/>
+          </a:p>
+        </p:txBody>
+      </p:sp>
+      <p:sp>
+        <p:nvSpPr>
+          <p:cNvPr id="8" name="TextBox 7"/>
+          <p:cNvSpPr txBox="1"/>
+          <p:nvPr/>
+        </p:nvSpPr>
+        <p:spPr>
+          <a:xfrm>
+            <a:off x="2258568" y="2084832"/>
+            <a:ext cx="1005840" cy="320040"/>
+          </a:xfrm>
+          <a:prstGeom prst="rect">
+            <a:avLst/>
+          </a:prstGeom>
+          <a:noFill/>
+        </p:spPr>
+        <p:txBody>
+          <a:bodyPr wrap="square">
+            <a:spAutoFit/>
+          </a:bodyPr>
+          <a:lstStyle/>
+          <a:p>
+            <a:pPr algn="l"/>
+            <a:r>
+              <a:rPr sz="1600" b="1">
+                <a:solidFill>
+                  <a:srgbClr val="2DD4BF"/>
+                </a:solidFill>
+                <a:latin typeface="Aptos"/>
+              </a:rPr>
+              <a:t>2</a:t>
+            </a:r>
+          </a:p>
+        </p:txBody>
+      </p:sp>
+      <p:sp>
+        <p:nvSpPr>
+          <p:cNvPr id="9" name="TextBox 8"/>
+          <p:cNvSpPr txBox="1"/>
+          <p:nvPr/>
+        </p:nvSpPr>
+        <p:spPr>
+          <a:xfrm>
+            <a:off x="2258568" y="2514600"/>
+            <a:ext cx="1005840" cy="777239"/>
+          </a:xfrm>
+          <a:prstGeom prst="rect">
+            <a:avLst/>
+          </a:prstGeom>
+          <a:noFill/>
+        </p:spPr>
+        <p:txBody>
+          <a:bodyPr wrap="square">
+            <a:spAutoFit/>
+          </a:bodyPr>
+          <a:lstStyle/>
+          <a:p>
+            <a:pPr algn="l"/>
+            <a:r>
+              <a:rPr sz="1200" b="0">
+                <a:solidFill>
+                  <a:srgbClr val="E5EDF7"/>
+                </a:solidFill>
+                <a:latin typeface="Aptos"/>
+              </a:rPr>
+              <a:t>User + role
+loaded</a:t>
+            </a:r>
+          </a:p>
+        </p:txBody>
+      </p:sp>
+      <p:sp>
+        <p:nvSpPr>
+          <p:cNvPr id="10" name="Rounded Rectangle 9"/>
+          <p:cNvSpPr/>
+          <p:nvPr/>
+        </p:nvSpPr>
+        <p:spPr>
+          <a:xfrm>
+            <a:off x="3739896" y="1920240"/>
+            <a:ext cx="1371600" cy="1508760"/>
+          </a:xfrm>
+          <a:prstGeom prst="roundRect">
+            <a:avLst/>
+          </a:prstGeom>
+          <a:solidFill>
+            <a:srgbClr val="111A2D"/>
+          </a:solidFill>
+          <a:ln>
+            <a:solidFill>
+              <a:srgbClr val="2D3A52"/>
+            </a:solidFill>
+          </a:ln>
+        </p:spPr>
+        <p:style>
+          <a:lnRef idx="1">
+            <a:schemeClr val="accent1"/>
+          </a:lnRef>
+          <a:fillRef idx="3">
+            <a:schemeClr val="accent1"/>
+          </a:fillRef>
+          <a:effectRef idx="2">
+            <a:schemeClr val="accent1"/>
+          </a:effectRef>
+          <a:fontRef idx="minor">
+            <a:schemeClr val="lt1"/>
+          </a:fontRef>
+        </p:style>
+        <p:txBody>
+          <a:bodyPr rtlCol="0" anchor="ctr"/>
+          <a:lstStyle/>
+          <a:p>
+            <a:pPr algn="ctr"/>
+          </a:p>
+        </p:txBody>
+      </p:sp>
+      <p:sp>
+        <p:nvSpPr>
+          <p:cNvPr id="11" name="TextBox 10"/>
+          <p:cNvSpPr txBox="1"/>
+          <p:nvPr/>
+        </p:nvSpPr>
+        <p:spPr>
+          <a:xfrm>
+            <a:off x="3922776" y="2084832"/>
+            <a:ext cx="1005840" cy="320040"/>
+          </a:xfrm>
+          <a:prstGeom prst="rect">
+            <a:avLst/>
+          </a:prstGeom>
+          <a:noFill/>
+        </p:spPr>
+        <p:txBody>
+          <a:bodyPr wrap="square">
+            <a:spAutoFit/>
+          </a:bodyPr>
+          <a:lstStyle/>
+          <a:p>
+            <a:pPr algn="l"/>
+            <a:r>
+              <a:rPr sz="1600" b="1">
+                <a:solidFill>
+                  <a:srgbClr val="2DD4BF"/>
+                </a:solidFill>
+                <a:latin typeface="Aptos"/>
+              </a:rPr>
+              <a:t>3</a:t>
+            </a:r>
+          </a:p>
+        </p:txBody>
+      </p:sp>
+      <p:sp>
+        <p:nvSpPr>
+          <p:cNvPr id="12" name="TextBox 11"/>
+          <p:cNvSpPr txBox="1"/>
+          <p:nvPr/>
+        </p:nvSpPr>
+        <p:spPr>
+          <a:xfrm>
+            <a:off x="3922776" y="2514600"/>
+            <a:ext cx="1005840" cy="777239"/>
+          </a:xfrm>
+          <a:prstGeom prst="rect">
+            <a:avLst/>
+          </a:prstGeom>
+          <a:noFill/>
+        </p:spPr>
+        <p:txBody>
+          <a:bodyPr wrap="square">
+            <a:spAutoFit/>
+          </a:bodyPr>
+          <a:lstStyle/>
+          <a:p>
+            <a:pPr algn="l"/>
+            <a:r>
+              <a:rPr sz="1200" b="0">
+                <a:solidFill>
+                  <a:srgbClr val="E5EDF7"/>
+                </a:solidFill>
+                <a:latin typeface="Aptos"/>
+              </a:rPr>
+              <a:t>Tenant ID
+resolved</a:t>
+            </a:r>
+          </a:p>
+        </p:txBody>
+      </p:sp>
+      <p:sp>
+        <p:nvSpPr>
+          <p:cNvPr id="13" name="Rounded Rectangle 12"/>
+          <p:cNvSpPr/>
+          <p:nvPr/>
+        </p:nvSpPr>
+        <p:spPr>
+          <a:xfrm>
+            <a:off x="5404104" y="1920240"/>
+            <a:ext cx="1371600" cy="1508760"/>
+          </a:xfrm>
+          <a:prstGeom prst="roundRect">
+            <a:avLst/>
+          </a:prstGeom>
+          <a:solidFill>
+            <a:srgbClr val="111A2D"/>
+          </a:solidFill>
+          <a:ln>
+            <a:solidFill>
+              <a:srgbClr val="2D3A52"/>
+            </a:solidFill>
+          </a:ln>
+        </p:spPr>
+        <p:style>
+          <a:lnRef idx="1">
+            <a:schemeClr val="accent1"/>
+          </a:lnRef>
+          <a:fillRef idx="3">
+            <a:schemeClr val="accent1"/>
+          </a:fillRef>
+          <a:effectRef idx="2">
+            <a:schemeClr val="accent1"/>
+          </a:effectRef>
+          <a:fontRef idx="minor">
+            <a:schemeClr val="lt1"/>
+          </a:fontRef>
+        </p:style>
+        <p:txBody>
+          <a:bodyPr rtlCol="0" anchor="ctr"/>
+          <a:lstStyle/>
+          <a:p>
+            <a:pPr algn="ctr"/>
+          </a:p>
+        </p:txBody>
+      </p:sp>
+      <p:sp>
+        <p:nvSpPr>
+          <p:cNvPr id="14" name="TextBox 13"/>
+          <p:cNvSpPr txBox="1"/>
+          <p:nvPr/>
+        </p:nvSpPr>
+        <p:spPr>
+          <a:xfrm>
+            <a:off x="5586984" y="2084832"/>
+            <a:ext cx="1005840" cy="320040"/>
+          </a:xfrm>
+          <a:prstGeom prst="rect">
+            <a:avLst/>
+          </a:prstGeom>
+          <a:noFill/>
+        </p:spPr>
+        <p:txBody>
+          <a:bodyPr wrap="square">
+            <a:spAutoFit/>
+          </a:bodyPr>
+          <a:lstStyle/>
+          <a:p>
+            <a:pPr algn="l"/>
+            <a:r>
+              <a:rPr sz="1600" b="1">
+                <a:solidFill>
+                  <a:srgbClr val="2DD4BF"/>
+                </a:solidFill>
+                <a:latin typeface="Aptos"/>
+              </a:rPr>
+              <a:t>4</a:t>
+            </a:r>
+          </a:p>
+        </p:txBody>
+      </p:sp>
+      <p:sp>
+        <p:nvSpPr>
+          <p:cNvPr id="15" name="TextBox 14"/>
+          <p:cNvSpPr txBox="1"/>
+          <p:nvPr/>
+        </p:nvSpPr>
+        <p:spPr>
+          <a:xfrm>
+            <a:off x="5586984" y="2514600"/>
+            <a:ext cx="1005840" cy="777239"/>
+          </a:xfrm>
+          <a:prstGeom prst="rect">
+            <a:avLst/>
+          </a:prstGeom>
+          <a:noFill/>
+        </p:spPr>
+        <p:txBody>
+          <a:bodyPr wrap="square">
+            <a:spAutoFit/>
+          </a:bodyPr>
+          <a:lstStyle/>
+          <a:p>
+            <a:pPr algn="l"/>
+            <a:r>
+              <a:rPr sz="1200" b="0">
+                <a:solidFill>
+                  <a:srgbClr val="E5EDF7"/>
+                </a:solidFill>
+                <a:latin typeface="Aptos"/>
+              </a:rPr>
+              <a:t>Documents
+filtered</a:t>
+            </a:r>
+          </a:p>
+        </p:txBody>
+      </p:sp>
+      <p:sp>
+        <p:nvSpPr>
+          <p:cNvPr id="16" name="Rounded Rectangle 15"/>
+          <p:cNvSpPr/>
+          <p:nvPr/>
+        </p:nvSpPr>
+        <p:spPr>
+          <a:xfrm>
+            <a:off x="7068312" y="1920240"/>
+            <a:ext cx="1371600" cy="1508760"/>
+          </a:xfrm>
+          <a:prstGeom prst="roundRect">
+            <a:avLst/>
+          </a:prstGeom>
+          <a:solidFill>
+            <a:srgbClr val="111A2D"/>
+          </a:solidFill>
+          <a:ln>
+            <a:solidFill>
+              <a:srgbClr val="2D3A52"/>
+            </a:solidFill>
+          </a:ln>
+        </p:spPr>
+        <p:style>
+          <a:lnRef idx="1">
+            <a:schemeClr val="accent1"/>
+          </a:lnRef>
+          <a:fillRef idx="3">
+            <a:schemeClr val="accent1"/>
+          </a:fillRef>
+          <a:effectRef idx="2">
+            <a:schemeClr val="accent1"/>
+          </a:effectRef>
+          <a:fontRef idx="minor">
+            <a:schemeClr val="lt1"/>
+          </a:fontRef>
+        </p:style>
+        <p:txBody>
+          <a:bodyPr rtlCol="0" anchor="ctr"/>
+          <a:lstStyle/>
+          <a:p>
+            <a:pPr algn="ctr"/>
+          </a:p>
+        </p:txBody>
+      </p:sp>
+      <p:sp>
+        <p:nvSpPr>
+          <p:cNvPr id="17" name="TextBox 16"/>
+          <p:cNvSpPr txBox="1"/>
+          <p:nvPr/>
+        </p:nvSpPr>
+        <p:spPr>
+          <a:xfrm>
+            <a:off x="7251192" y="2084832"/>
+            <a:ext cx="1005840" cy="320040"/>
+          </a:xfrm>
+          <a:prstGeom prst="rect">
+            <a:avLst/>
+          </a:prstGeom>
+          <a:noFill/>
+        </p:spPr>
+        <p:txBody>
+          <a:bodyPr wrap="square">
+            <a:spAutoFit/>
+          </a:bodyPr>
+          <a:lstStyle/>
+          <a:p>
+            <a:pPr algn="l"/>
+            <a:r>
+              <a:rPr sz="1600" b="1">
+                <a:solidFill>
+                  <a:srgbClr val="2DD4BF"/>
+                </a:solidFill>
+                <a:latin typeface="Aptos"/>
+              </a:rPr>
+              <a:t>5</a:t>
+            </a:r>
+          </a:p>
+        </p:txBody>
+      </p:sp>
+      <p:sp>
+        <p:nvSpPr>
+          <p:cNvPr id="18" name="TextBox 17"/>
+          <p:cNvSpPr txBox="1"/>
+          <p:nvPr/>
+        </p:nvSpPr>
+        <p:spPr>
+          <a:xfrm>
+            <a:off x="7251192" y="2514600"/>
+            <a:ext cx="1005840" cy="777239"/>
+          </a:xfrm>
+          <a:prstGeom prst="rect">
+            <a:avLst/>
+          </a:prstGeom>
+          <a:noFill/>
+        </p:spPr>
+        <p:txBody>
+          <a:bodyPr wrap="square">
+            <a:spAutoFit/>
+          </a:bodyPr>
+          <a:lstStyle/>
+          <a:p>
+            <a:pPr algn="l"/>
+            <a:r>
+              <a:rPr sz="1200" b="0">
+                <a:solidFill>
+                  <a:srgbClr val="E5EDF7"/>
+                </a:solidFill>
+                <a:latin typeface="Aptos"/>
+              </a:rPr>
+              <a:t>Chunks
+retrieved</a:t>
+            </a:r>
+          </a:p>
+        </p:txBody>
+      </p:sp>
+      <p:sp>
+        <p:nvSpPr>
+          <p:cNvPr id="19" name="Rounded Rectangle 18"/>
+          <p:cNvSpPr/>
+          <p:nvPr/>
+        </p:nvSpPr>
+        <p:spPr>
+          <a:xfrm>
+            <a:off x="8732519" y="1920240"/>
+            <a:ext cx="1371600" cy="1508760"/>
+          </a:xfrm>
+          <a:prstGeom prst="roundRect">
+            <a:avLst/>
+          </a:prstGeom>
+          <a:solidFill>
+            <a:srgbClr val="111A2D"/>
+          </a:solidFill>
+          <a:ln>
+            <a:solidFill>
+              <a:srgbClr val="2D3A52"/>
+            </a:solidFill>
+          </a:ln>
+        </p:spPr>
+        <p:style>
+          <a:lnRef idx="1">
+            <a:schemeClr val="accent1"/>
+          </a:lnRef>
+          <a:fillRef idx="3">
+            <a:schemeClr val="accent1"/>
+          </a:fillRef>
+          <a:effectRef idx="2">
+            <a:schemeClr val="accent1"/>
+          </a:effectRef>
+          <a:fontRef idx="minor">
+            <a:schemeClr val="lt1"/>
+          </a:fontRef>
+        </p:style>
+        <p:txBody>
+          <a:bodyPr rtlCol="0" anchor="ctr"/>
+          <a:lstStyle/>
+          <a:p>
+            <a:pPr algn="ctr"/>
+          </a:p>
+        </p:txBody>
+      </p:sp>
+      <p:sp>
+        <p:nvSpPr>
+          <p:cNvPr id="20" name="TextBox 19"/>
+          <p:cNvSpPr txBox="1"/>
+          <p:nvPr/>
+        </p:nvSpPr>
+        <p:spPr>
+          <a:xfrm>
+            <a:off x="8915399" y="2084832"/>
+            <a:ext cx="1005840" cy="320040"/>
+          </a:xfrm>
+          <a:prstGeom prst="rect">
+            <a:avLst/>
+          </a:prstGeom>
+          <a:noFill/>
+        </p:spPr>
+        <p:txBody>
+          <a:bodyPr wrap="square">
+            <a:spAutoFit/>
+          </a:bodyPr>
+          <a:lstStyle/>
+          <a:p>
+            <a:pPr algn="l"/>
+            <a:r>
+              <a:rPr sz="1600" b="1">
+                <a:solidFill>
+                  <a:srgbClr val="2DD4BF"/>
+                </a:solidFill>
+                <a:latin typeface="Aptos"/>
+              </a:rPr>
+              <a:t>6</a:t>
+            </a:r>
+          </a:p>
+        </p:txBody>
+      </p:sp>
+      <p:sp>
+        <p:nvSpPr>
+          <p:cNvPr id="21" name="TextBox 20"/>
+          <p:cNvSpPr txBox="1"/>
+          <p:nvPr/>
+        </p:nvSpPr>
+        <p:spPr>
+          <a:xfrm>
+            <a:off x="8915399" y="2514600"/>
+            <a:ext cx="1005840" cy="777239"/>
+          </a:xfrm>
+          <a:prstGeom prst="rect">
+            <a:avLst/>
+          </a:prstGeom>
+          <a:noFill/>
+        </p:spPr>
+        <p:txBody>
+          <a:bodyPr wrap="square">
+            <a:spAutoFit/>
+          </a:bodyPr>
+          <a:lstStyle/>
+          <a:p>
+            <a:pPr algn="l"/>
+            <a:r>
+              <a:rPr sz="1200" b="0">
+                <a:solidFill>
+                  <a:srgbClr val="E5EDF7"/>
+                </a:solidFill>
+                <a:latin typeface="Aptos"/>
+              </a:rPr>
+              <a:t>Answer +
+citations</a:t>
+            </a:r>
+          </a:p>
+        </p:txBody>
+      </p:sp>
+      <p:sp>
+        <p:nvSpPr>
+          <p:cNvPr id="22" name="Rounded Rectangle 21"/>
+          <p:cNvSpPr/>
+          <p:nvPr/>
+        </p:nvSpPr>
+        <p:spPr>
+          <a:xfrm>
+            <a:off x="10396728" y="1920240"/>
+            <a:ext cx="1371600" cy="1508760"/>
+          </a:xfrm>
+          <a:prstGeom prst="roundRect">
+            <a:avLst/>
+          </a:prstGeom>
+          <a:solidFill>
+            <a:srgbClr val="111A2D"/>
+          </a:solidFill>
+          <a:ln>
+            <a:solidFill>
+              <a:srgbClr val="2D3A52"/>
+            </a:solidFill>
+          </a:ln>
+        </p:spPr>
+        <p:style>
+          <a:lnRef idx="1">
+            <a:schemeClr val="accent1"/>
+          </a:lnRef>
+          <a:fillRef idx="3">
+            <a:schemeClr val="accent1"/>
+          </a:fillRef>
+          <a:effectRef idx="2">
+            <a:schemeClr val="accent1"/>
+          </a:effectRef>
+          <a:fontRef idx="minor">
+            <a:schemeClr val="lt1"/>
+          </a:fontRef>
+        </p:style>
+        <p:txBody>
+          <a:bodyPr rtlCol="0" anchor="ctr"/>
+          <a:lstStyle/>
+          <a:p>
+            <a:pPr algn="ctr"/>
+          </a:p>
+        </p:txBody>
+      </p:sp>
+      <p:sp>
+        <p:nvSpPr>
+          <p:cNvPr id="23" name="TextBox 22"/>
+          <p:cNvSpPr txBox="1"/>
+          <p:nvPr/>
+        </p:nvSpPr>
+        <p:spPr>
+          <a:xfrm>
+            <a:off x="10579607" y="2084832"/>
+            <a:ext cx="1005840" cy="320040"/>
+          </a:xfrm>
+          <a:prstGeom prst="rect">
+            <a:avLst/>
+          </a:prstGeom>
+          <a:noFill/>
+        </p:spPr>
+        <p:txBody>
+          <a:bodyPr wrap="square">
+            <a:spAutoFit/>
+          </a:bodyPr>
+          <a:lstStyle/>
+          <a:p>
+            <a:pPr algn="l"/>
+            <a:r>
+              <a:rPr sz="1600" b="1">
+                <a:solidFill>
+                  <a:srgbClr val="2DD4BF"/>
+                </a:solidFill>
+                <a:latin typeface="Aptos"/>
+              </a:rPr>
+              <a:t>7</a:t>
+            </a:r>
+          </a:p>
+        </p:txBody>
+      </p:sp>
+      <p:sp>
+        <p:nvSpPr>
+          <p:cNvPr id="24" name="TextBox 23"/>
+          <p:cNvSpPr txBox="1"/>
+          <p:nvPr/>
+        </p:nvSpPr>
+        <p:spPr>
+          <a:xfrm>
+            <a:off x="10579607" y="2514600"/>
+            <a:ext cx="1005840" cy="777239"/>
+          </a:xfrm>
+          <a:prstGeom prst="rect">
+            <a:avLst/>
+          </a:prstGeom>
+          <a:noFill/>
+        </p:spPr>
+        <p:txBody>
+          <a:bodyPr wrap="square">
+            <a:spAutoFit/>
+          </a:bodyPr>
+          <a:lstStyle/>
+          <a:p>
+            <a:pPr algn="l"/>
+            <a:r>
+              <a:rPr sz="1200" b="0">
+                <a:solidFill>
+                  <a:srgbClr val="E5EDF7"/>
+                </a:solidFill>
+                <a:latin typeface="Aptos"/>
+              </a:rPr>
+              <a:t>Audit
+written</a:t>
+            </a:r>
+          </a:p>
+        </p:txBody>
+      </p:sp>
+      <p:sp>
+        <p:nvSpPr>
+          <p:cNvPr id="25" name="TextBox 24"/>
+          <p:cNvSpPr txBox="1"/>
+          <p:nvPr/>
+        </p:nvSpPr>
+        <p:spPr>
+          <a:xfrm>
+            <a:off x="914400" y="4251960"/>
+            <a:ext cx="10241280" cy="411480"/>
+          </a:xfrm>
+          <a:prstGeom prst="rect">
+            <a:avLst/>
+          </a:prstGeom>
+          <a:noFill/>
+        </p:spPr>
+        <p:txBody>
+          <a:bodyPr wrap="square">
+            <a:spAutoFit/>
+          </a:bodyPr>
+          <a:lstStyle/>
+          <a:p>
+            <a:pPr algn="ctr"/>
+            <a:r>
+              <a:rPr sz="1700" b="0">
+                <a:solidFill>
+                  <a:srgbClr val="E5EDF7"/>
+                </a:solidFill>
+                <a:latin typeface="Aptos"/>
+              </a:rPr>
+              <a:t>Client input: question only. Tenant identity, ownership, and authorization are server decisions.</a:t>
+            </a:r>
+          </a:p>
+        </p:txBody>
+      </p:sp>
+      <p:sp>
+        <p:nvSpPr>
+          <p:cNvPr id="26" name="TextBox 25"/>
+          <p:cNvSpPr txBox="1"/>
+          <p:nvPr/>
+        </p:nvSpPr>
+        <p:spPr>
+          <a:xfrm>
+            <a:off x="822960" y="5074920"/>
+            <a:ext cx="10515600" cy="457200"/>
+          </a:xfrm>
+          <a:prstGeom prst="rect">
+            <a:avLst/>
+          </a:prstGeom>
+          <a:noFill/>
+        </p:spPr>
+        <p:txBody>
+          <a:bodyPr wrap="square">
+            <a:spAutoFit/>
+          </a:bodyPr>
+          <a:lstStyle/>
+          <a:p>
+            <a:pPr algn="ctr"/>
+            <a:r>
+              <a:rPr sz="1500" b="0">
+                <a:solidFill>
+                  <a:srgbClr val="2DD4BF"/>
+                </a:solidFill>
+                <a:latin typeface="Aptos"/>
+              </a:rPr>
+              <a:t>Failure paths are explicit: 401 unauthenticated, 403 insufficient role, 404 hidden cross-tenant resource, or a grounded refusal.</a:t>
+            </a:r>
+          </a:p>
+        </p:txBody>
+      </p:sp>
+    </p:spTree>
+  </p:cSld>
+  <p:clrMapOvr>
+    <a:masterClrMapping/>
+  </p:clrMapOvr>
+</p:sld>
+</file>
+
+<file path=ppt/slides/slide18.xml><?xml version="1.0" encoding="utf-8"?>
+<p:sld xmlns:a="http://schemas.openxmlformats.org/drawingml/2006/main" xmlns:p="http://schemas.openxmlformats.org/presentationml/2006/main" xmlns:r="http://schemas.openxmlformats.org/officeDocument/2006/relationships">
+  <p:cSld>
+    <p:bg>
+      <p:bgPr>
+        <a:solidFill>
+          <a:srgbClr val="0B1120"/>
+        </a:solidFill>
+        <a:effectLst/>
+      </p:bgPr>
+    </p:bg>
+    <p:spTree>
+      <p:nvGrpSpPr>
+        <p:cNvPr id="1" name=""/>
+        <p:cNvGrpSpPr/>
+        <p:nvPr/>
+      </p:nvGrpSpPr>
+      <p:grpSpPr/>
+      <p:sp>
+        <p:nvSpPr>
+          <p:cNvPr id="2" name="TextBox 1"/>
+          <p:cNvSpPr txBox="1"/>
+          <p:nvPr/>
+        </p:nvSpPr>
+        <p:spPr>
+          <a:xfrm>
+            <a:off x="594360" y="411480"/>
+            <a:ext cx="10972800" cy="502920"/>
+          </a:xfrm>
+          <a:prstGeom prst="rect">
+            <a:avLst/>
+          </a:prstGeom>
+          <a:noFill/>
+        </p:spPr>
+        <p:txBody>
+          <a:bodyPr wrap="square">
+            <a:spAutoFit/>
+          </a:bodyPr>
+          <a:lstStyle/>
+          <a:p>
+            <a:pPr algn="l"/>
+            <a:r>
+              <a:rPr sz="2800" b="1">
+                <a:solidFill>
+                  <a:srgbClr val="E5EDF7"/>
+                </a:solidFill>
+                <a:latin typeface="Aptos"/>
+              </a:rPr>
+              <a:t>Telegram assistant</a:t>
+            </a:r>
+          </a:p>
+        </p:txBody>
+      </p:sp>
+      <p:sp>
+        <p:nvSpPr>
+          <p:cNvPr id="3" name="TextBox 2"/>
+          <p:cNvSpPr txBox="1"/>
+          <p:nvPr/>
+        </p:nvSpPr>
+        <p:spPr>
+          <a:xfrm>
+            <a:off x="621792" y="987552"/>
+            <a:ext cx="10789920" cy="320040"/>
+          </a:xfrm>
+          <a:prstGeom prst="rect">
+            <a:avLst/>
+          </a:prstGeom>
+          <a:noFill/>
+        </p:spPr>
+        <p:txBody>
+          <a:bodyPr wrap="square">
+            <a:spAutoFit/>
+          </a:bodyPr>
+          <a:lstStyle/>
+          <a:p>
+            <a:pPr algn="l"/>
+            <a:r>
+              <a:rPr sz="1200" b="0">
+                <a:solidFill>
+                  <a:srgbClr val="94A3B8"/>
+                </a:solidFill>
+                <a:latin typeface="Aptos"/>
+              </a:rPr>
+              <a:t>The bot uses the same tenant-scoped backend concepts instead of creating a second data silo.</a:t>
+            </a:r>
+          </a:p>
+        </p:txBody>
+      </p:sp>
+      <p:sp>
+        <p:nvSpPr>
+          <p:cNvPr id="4" name="Rounded Rectangle 3"/>
+          <p:cNvSpPr/>
+          <p:nvPr/>
+        </p:nvSpPr>
+        <p:spPr>
+          <a:xfrm>
+            <a:off x="685800" y="1600200"/>
+            <a:ext cx="3474720" cy="3520440"/>
+          </a:xfrm>
+          <a:prstGeom prst="roundRect">
+            <a:avLst/>
+          </a:prstGeom>
+          <a:solidFill>
+            <a:srgbClr val="111A2D"/>
+          </a:solidFill>
+          <a:ln>
+            <a:solidFill>
+              <a:srgbClr val="2D3A52"/>
+            </a:solidFill>
+          </a:ln>
+        </p:spPr>
+        <p:style>
+          <a:lnRef idx="1">
+            <a:schemeClr val="accent1"/>
+          </a:lnRef>
+          <a:fillRef idx="3">
+            <a:schemeClr val="accent1"/>
+          </a:fillRef>
+          <a:effectRef idx="2">
+            <a:schemeClr val="accent1"/>
+          </a:effectRef>
+          <a:fontRef idx="minor">
+            <a:schemeClr val="lt1"/>
+          </a:fontRef>
+        </p:style>
+        <p:txBody>
+          <a:bodyPr rtlCol="0" anchor="ctr"/>
+          <a:lstStyle/>
+          <a:p>
+            <a:pPr algn="ctr"/>
+          </a:p>
+        </p:txBody>
+      </p:sp>
+      <p:sp>
+        <p:nvSpPr>
+          <p:cNvPr id="5" name="TextBox 4"/>
+          <p:cNvSpPr txBox="1"/>
+          <p:nvPr/>
+        </p:nvSpPr>
+        <p:spPr>
+          <a:xfrm>
+            <a:off x="868680" y="1764792"/>
             <a:ext cx="3108960" cy="320040"/>
           </a:xfrm>
           <a:prstGeom prst="rect">
@@ -6365,7 +7841,245 @@
                 </a:solidFill>
                 <a:latin typeface="Aptos"/>
               </a:rPr>
-              <a:t>Future</a:t>
+              <a:t>Authentication</a:t>
+            </a:r>
+          </a:p>
+        </p:txBody>
+      </p:sp>
+      <p:sp>
+        <p:nvSpPr>
+          <p:cNvPr id="6" name="TextBox 5"/>
+          <p:cNvSpPr txBox="1"/>
+          <p:nvPr/>
+        </p:nvSpPr>
+        <p:spPr>
+          <a:xfrm>
+            <a:off x="868680" y="2194560"/>
+            <a:ext cx="3108960" cy="2788920"/>
+          </a:xfrm>
+          <a:prstGeom prst="rect">
+            <a:avLst/>
+          </a:prstGeom>
+          <a:noFill/>
+        </p:spPr>
+        <p:txBody>
+          <a:bodyPr wrap="square">
+            <a:spAutoFit/>
+          </a:bodyPr>
+          <a:lstStyle/>
+          <a:p>
+            <a:pPr algn="l"/>
+            <a:r>
+              <a:rPr sz="1200" b="0">
+                <a:solidFill>
+                  <a:srgbClr val="E5EDF7"/>
+                </a:solidFill>
+                <a:latin typeface="Aptos"/>
+              </a:rPr>
+              <a:t>/start and login flow
+Tenant-aware Telegram session
+120-second sliding inactivity timeout
+Session state persisted in the database</a:t>
+            </a:r>
+          </a:p>
+        </p:txBody>
+      </p:sp>
+      <p:sp>
+        <p:nvSpPr>
+          <p:cNvPr id="7" name="Rounded Rectangle 6"/>
+          <p:cNvSpPr/>
+          <p:nvPr/>
+        </p:nvSpPr>
+        <p:spPr>
+          <a:xfrm>
+            <a:off x="4389120" y="1600200"/>
+            <a:ext cx="3474720" cy="3520440"/>
+          </a:xfrm>
+          <a:prstGeom prst="roundRect">
+            <a:avLst/>
+          </a:prstGeom>
+          <a:solidFill>
+            <a:srgbClr val="111A2D"/>
+          </a:solidFill>
+          <a:ln>
+            <a:solidFill>
+              <a:srgbClr val="2D3A52"/>
+            </a:solidFill>
+          </a:ln>
+        </p:spPr>
+        <p:style>
+          <a:lnRef idx="1">
+            <a:schemeClr val="accent1"/>
+          </a:lnRef>
+          <a:fillRef idx="3">
+            <a:schemeClr val="accent1"/>
+          </a:fillRef>
+          <a:effectRef idx="2">
+            <a:schemeClr val="accent1"/>
+          </a:effectRef>
+          <a:fontRef idx="minor">
+            <a:schemeClr val="lt1"/>
+          </a:fontRef>
+        </p:style>
+        <p:txBody>
+          <a:bodyPr rtlCol="0" anchor="ctr"/>
+          <a:lstStyle/>
+          <a:p>
+            <a:pPr algn="ctr"/>
+          </a:p>
+        </p:txBody>
+      </p:sp>
+      <p:sp>
+        <p:nvSpPr>
+          <p:cNvPr id="8" name="TextBox 7"/>
+          <p:cNvSpPr txBox="1"/>
+          <p:nvPr/>
+        </p:nvSpPr>
+        <p:spPr>
+          <a:xfrm>
+            <a:off x="4572000" y="1764792"/>
+            <a:ext cx="3108960" cy="320040"/>
+          </a:xfrm>
+          <a:prstGeom prst="rect">
+            <a:avLst/>
+          </a:prstGeom>
+          <a:noFill/>
+        </p:spPr>
+        <p:txBody>
+          <a:bodyPr wrap="square">
+            <a:spAutoFit/>
+          </a:bodyPr>
+          <a:lstStyle/>
+          <a:p>
+            <a:pPr algn="l"/>
+            <a:r>
+              <a:rPr sz="1600" b="1">
+                <a:solidFill>
+                  <a:srgbClr val="2DD4BF"/>
+                </a:solidFill>
+                <a:latin typeface="Aptos"/>
+              </a:rPr>
+              <a:t>Commands</a:t>
+            </a:r>
+          </a:p>
+        </p:txBody>
+      </p:sp>
+      <p:sp>
+        <p:nvSpPr>
+          <p:cNvPr id="9" name="TextBox 8"/>
+          <p:cNvSpPr txBox="1"/>
+          <p:nvPr/>
+        </p:nvSpPr>
+        <p:spPr>
+          <a:xfrm>
+            <a:off x="4572000" y="2194560"/>
+            <a:ext cx="3108960" cy="2788920"/>
+          </a:xfrm>
+          <a:prstGeom prst="rect">
+            <a:avLst/>
+          </a:prstGeom>
+          <a:noFill/>
+        </p:spPr>
+        <p:txBody>
+          <a:bodyPr wrap="square">
+            <a:spAutoFit/>
+          </a:bodyPr>
+          <a:lstStyle/>
+          <a:p>
+            <a:pPr algn="l"/>
+            <a:r>
+              <a:rPr sz="1200" b="0">
+                <a:solidFill>
+                  <a:srgbClr val="E5EDF7"/>
+                </a:solidFill>
+                <a:latin typeface="Aptos"/>
+              </a:rPr>
+              <a:t>/chat
+/documents
+/upload
+/conversations
+/audits
+/telemetry</a:t>
+            </a:r>
+          </a:p>
+        </p:txBody>
+      </p:sp>
+      <p:sp>
+        <p:nvSpPr>
+          <p:cNvPr id="10" name="Rounded Rectangle 9"/>
+          <p:cNvSpPr/>
+          <p:nvPr/>
+        </p:nvSpPr>
+        <p:spPr>
+          <a:xfrm>
+            <a:off x="8092440" y="1600200"/>
+            <a:ext cx="3474720" cy="3520440"/>
+          </a:xfrm>
+          <a:prstGeom prst="roundRect">
+            <a:avLst/>
+          </a:prstGeom>
+          <a:solidFill>
+            <a:srgbClr val="111A2D"/>
+          </a:solidFill>
+          <a:ln>
+            <a:solidFill>
+              <a:srgbClr val="2D3A52"/>
+            </a:solidFill>
+          </a:ln>
+        </p:spPr>
+        <p:style>
+          <a:lnRef idx="1">
+            <a:schemeClr val="accent1"/>
+          </a:lnRef>
+          <a:fillRef idx="3">
+            <a:schemeClr val="accent1"/>
+          </a:fillRef>
+          <a:effectRef idx="2">
+            <a:schemeClr val="accent1"/>
+          </a:effectRef>
+          <a:fontRef idx="minor">
+            <a:schemeClr val="lt1"/>
+          </a:fontRef>
+        </p:style>
+        <p:txBody>
+          <a:bodyPr rtlCol="0" anchor="ctr"/>
+          <a:lstStyle/>
+          <a:p>
+            <a:pPr algn="ctr"/>
+          </a:p>
+        </p:txBody>
+      </p:sp>
+      <p:sp>
+        <p:nvSpPr>
+          <p:cNvPr id="11" name="TextBox 10"/>
+          <p:cNvSpPr txBox="1"/>
+          <p:nvPr/>
+        </p:nvSpPr>
+        <p:spPr>
+          <a:xfrm>
+            <a:off x="8275319" y="1764792"/>
+            <a:ext cx="3108960" cy="320040"/>
+          </a:xfrm>
+          <a:prstGeom prst="rect">
+            <a:avLst/>
+          </a:prstGeom>
+          <a:noFill/>
+        </p:spPr>
+        <p:txBody>
+          <a:bodyPr wrap="square">
+            <a:spAutoFit/>
+          </a:bodyPr>
+          <a:lstStyle/>
+          <a:p>
+            <a:pPr algn="l"/>
+            <a:r>
+              <a:rPr sz="1600" b="1">
+                <a:solidFill>
+                  <a:srgbClr val="2DD4BF"/>
+                </a:solidFill>
+                <a:latin typeface="Aptos"/>
+              </a:rPr>
+              <a:t>Administration</a:t>
             </a:r>
           </a:p>
         </p:txBody>
@@ -6378,8 +8092,8 @@
         </p:nvSpPr>
         <p:spPr>
           <a:xfrm>
-            <a:off x="8275319" y="2240280"/>
-            <a:ext cx="3108960" cy="2560320"/>
+            <a:off x="8275319" y="2194560"/>
+            <a:ext cx="3108960" cy="2788920"/>
           </a:xfrm>
           <a:prstGeom prst="rect">
             <a:avLst/>
@@ -6400,7 +8114,11 @@
                 </a:solidFill>
                 <a:latin typeface="Aptos"/>
               </a:rPr>
-              <a:t>Async workers, OCR, object storage, richer feedback/export, and managed deployment verification.</a:t>
+              <a:t>/settings
+/setcompany
+/setdomain
+Admin-only settings changes
+Friendly upload success/failure responses</a:t>
             </a:r>
           </a:p>
         </p:txBody>
@@ -6413,8 +8131,8 @@
         </p:nvSpPr>
         <p:spPr>
           <a:xfrm>
-            <a:off x="914400" y="5715000"/>
-            <a:ext cx="10241280" cy="365760"/>
+            <a:off x="868680" y="5623560"/>
+            <a:ext cx="10424160" cy="320040"/>
           </a:xfrm>
           <a:prstGeom prst="rect">
             <a:avLst/>
@@ -6429,13 +8147,502 @@
           <a:p>
             <a:pPr algn="ctr"/>
             <a:r>
-              <a:rPr sz="1800" b="1">
+              <a:rPr sz="1400" b="0">
                 <a:solidFill>
                   <a:srgbClr val="2DD4BF"/>
                 </a:solidFill>
                 <a:latin typeface="Aptos"/>
               </a:rPr>
-              <a:t>Build trust into the architecture, then make the demo visible.</a:t>
+              <a:t>Operational rule: every authenticated command refreshes activity; only inactivity expires the session.</a:t>
+            </a:r>
+          </a:p>
+        </p:txBody>
+      </p:sp>
+    </p:spTree>
+  </p:cSld>
+  <p:clrMapOvr>
+    <a:masterClrMapping/>
+  </p:clrMapOvr>
+</p:sld>
+</file>
+
+<file path=ppt/slides/slide19.xml><?xml version="1.0" encoding="utf-8"?>
+<p:sld xmlns:a="http://schemas.openxmlformats.org/drawingml/2006/main" xmlns:p="http://schemas.openxmlformats.org/presentationml/2006/main" xmlns:r="http://schemas.openxmlformats.org/officeDocument/2006/relationships">
+  <p:cSld>
+    <p:bg>
+      <p:bgPr>
+        <a:solidFill>
+          <a:srgbClr val="0B1120"/>
+        </a:solidFill>
+        <a:effectLst/>
+      </p:bgPr>
+    </p:bg>
+    <p:spTree>
+      <p:nvGrpSpPr>
+        <p:cNvPr id="1" name=""/>
+        <p:cNvGrpSpPr/>
+        <p:nvPr/>
+      </p:nvGrpSpPr>
+      <p:grpSpPr/>
+      <p:sp>
+        <p:nvSpPr>
+          <p:cNvPr id="2" name="TextBox 1"/>
+          <p:cNvSpPr txBox="1"/>
+          <p:nvPr/>
+        </p:nvSpPr>
+        <p:spPr>
+          <a:xfrm>
+            <a:off x="594360" y="411480"/>
+            <a:ext cx="10972800" cy="502920"/>
+          </a:xfrm>
+          <a:prstGeom prst="rect">
+            <a:avLst/>
+          </a:prstGeom>
+          <a:noFill/>
+        </p:spPr>
+        <p:txBody>
+          <a:bodyPr wrap="square">
+            <a:spAutoFit/>
+          </a:bodyPr>
+          <a:lstStyle/>
+          <a:p>
+            <a:pPr algn="l"/>
+            <a:r>
+              <a:rPr sz="2800" b="1">
+                <a:solidFill>
+                  <a:srgbClr val="E5EDF7"/>
+                </a:solidFill>
+                <a:latin typeface="Aptos"/>
+              </a:rPr>
+              <a:t>Quality and verification</a:t>
+            </a:r>
+          </a:p>
+        </p:txBody>
+      </p:sp>
+      <p:sp>
+        <p:nvSpPr>
+          <p:cNvPr id="3" name="TextBox 2"/>
+          <p:cNvSpPr txBox="1"/>
+          <p:nvPr/>
+        </p:nvSpPr>
+        <p:spPr>
+          <a:xfrm>
+            <a:off x="621792" y="987552"/>
+            <a:ext cx="10789920" cy="320040"/>
+          </a:xfrm>
+          <a:prstGeom prst="rect">
+            <a:avLst/>
+          </a:prstGeom>
+          <a:noFill/>
+        </p:spPr>
+        <p:txBody>
+          <a:bodyPr wrap="square">
+            <a:spAutoFit/>
+          </a:bodyPr>
+          <a:lstStyle/>
+          <a:p>
+            <a:pPr algn="l"/>
+            <a:r>
+              <a:rPr sz="1200" b="0">
+                <a:solidFill>
+                  <a:srgbClr val="94A3B8"/>
+                </a:solidFill>
+                <a:latin typeface="Aptos"/>
+              </a:rPr>
+              <a:t>Evidence used to reduce regression risk before the jury demo.</a:t>
+            </a:r>
+          </a:p>
+        </p:txBody>
+      </p:sp>
+      <p:sp>
+        <p:nvSpPr>
+          <p:cNvPr id="4" name="Rounded Rectangle 3"/>
+          <p:cNvSpPr/>
+          <p:nvPr/>
+        </p:nvSpPr>
+        <p:spPr>
+          <a:xfrm>
+            <a:off x="685800" y="1600200"/>
+            <a:ext cx="3474720" cy="3474720"/>
+          </a:xfrm>
+          <a:prstGeom prst="roundRect">
+            <a:avLst/>
+          </a:prstGeom>
+          <a:solidFill>
+            <a:srgbClr val="111A2D"/>
+          </a:solidFill>
+          <a:ln>
+            <a:solidFill>
+              <a:srgbClr val="2D3A52"/>
+            </a:solidFill>
+          </a:ln>
+        </p:spPr>
+        <p:style>
+          <a:lnRef idx="1">
+            <a:schemeClr val="accent1"/>
+          </a:lnRef>
+          <a:fillRef idx="3">
+            <a:schemeClr val="accent1"/>
+          </a:fillRef>
+          <a:effectRef idx="2">
+            <a:schemeClr val="accent1"/>
+          </a:effectRef>
+          <a:fontRef idx="minor">
+            <a:schemeClr val="lt1"/>
+          </a:fontRef>
+        </p:style>
+        <p:txBody>
+          <a:bodyPr rtlCol="0" anchor="ctr"/>
+          <a:lstStyle/>
+          <a:p>
+            <a:pPr algn="ctr"/>
+          </a:p>
+        </p:txBody>
+      </p:sp>
+      <p:sp>
+        <p:nvSpPr>
+          <p:cNvPr id="5" name="TextBox 4"/>
+          <p:cNvSpPr txBox="1"/>
+          <p:nvPr/>
+        </p:nvSpPr>
+        <p:spPr>
+          <a:xfrm>
+            <a:off x="868680" y="1764792"/>
+            <a:ext cx="3108960" cy="320040"/>
+          </a:xfrm>
+          <a:prstGeom prst="rect">
+            <a:avLst/>
+          </a:prstGeom>
+          <a:noFill/>
+        </p:spPr>
+        <p:txBody>
+          <a:bodyPr wrap="square">
+            <a:spAutoFit/>
+          </a:bodyPr>
+          <a:lstStyle/>
+          <a:p>
+            <a:pPr algn="l"/>
+            <a:r>
+              <a:rPr sz="1600" b="1">
+                <a:solidFill>
+                  <a:srgbClr val="2DD4BF"/>
+                </a:solidFill>
+                <a:latin typeface="Aptos"/>
+              </a:rPr>
+              <a:t>Backend tests</a:t>
+            </a:r>
+          </a:p>
+        </p:txBody>
+      </p:sp>
+      <p:sp>
+        <p:nvSpPr>
+          <p:cNvPr id="6" name="TextBox 5"/>
+          <p:cNvSpPr txBox="1"/>
+          <p:nvPr/>
+        </p:nvSpPr>
+        <p:spPr>
+          <a:xfrm>
+            <a:off x="868680" y="2194560"/>
+            <a:ext cx="3108960" cy="2743200"/>
+          </a:xfrm>
+          <a:prstGeom prst="rect">
+            <a:avLst/>
+          </a:prstGeom>
+          <a:noFill/>
+        </p:spPr>
+        <p:txBody>
+          <a:bodyPr wrap="square">
+            <a:spAutoFit/>
+          </a:bodyPr>
+          <a:lstStyle/>
+          <a:p>
+            <a:pPr algn="l"/>
+            <a:r>
+              <a:rPr sz="1200" b="0">
+                <a:solidFill>
+                  <a:srgbClr val="E5EDF7"/>
+                </a:solidFill>
+                <a:latin typeface="Aptos"/>
+              </a:rPr>
+              <a:t>Authentication and verification
+Tenant authorization
+Admin access
+Document lifecycle
+RAG citations
+Telegram session expiry</a:t>
+            </a:r>
+          </a:p>
+        </p:txBody>
+      </p:sp>
+      <p:sp>
+        <p:nvSpPr>
+          <p:cNvPr id="7" name="Rounded Rectangle 6"/>
+          <p:cNvSpPr/>
+          <p:nvPr/>
+        </p:nvSpPr>
+        <p:spPr>
+          <a:xfrm>
+            <a:off x="4389120" y="1600200"/>
+            <a:ext cx="3474720" cy="3474720"/>
+          </a:xfrm>
+          <a:prstGeom prst="roundRect">
+            <a:avLst/>
+          </a:prstGeom>
+          <a:solidFill>
+            <a:srgbClr val="111A2D"/>
+          </a:solidFill>
+          <a:ln>
+            <a:solidFill>
+              <a:srgbClr val="2D3A52"/>
+            </a:solidFill>
+          </a:ln>
+        </p:spPr>
+        <p:style>
+          <a:lnRef idx="1">
+            <a:schemeClr val="accent1"/>
+          </a:lnRef>
+          <a:fillRef idx="3">
+            <a:schemeClr val="accent1"/>
+          </a:fillRef>
+          <a:effectRef idx="2">
+            <a:schemeClr val="accent1"/>
+          </a:effectRef>
+          <a:fontRef idx="minor">
+            <a:schemeClr val="lt1"/>
+          </a:fontRef>
+        </p:style>
+        <p:txBody>
+          <a:bodyPr rtlCol="0" anchor="ctr"/>
+          <a:lstStyle/>
+          <a:p>
+            <a:pPr algn="ctr"/>
+          </a:p>
+        </p:txBody>
+      </p:sp>
+      <p:sp>
+        <p:nvSpPr>
+          <p:cNvPr id="8" name="TextBox 7"/>
+          <p:cNvSpPr txBox="1"/>
+          <p:nvPr/>
+        </p:nvSpPr>
+        <p:spPr>
+          <a:xfrm>
+            <a:off x="4572000" y="1764792"/>
+            <a:ext cx="3108960" cy="320040"/>
+          </a:xfrm>
+          <a:prstGeom prst="rect">
+            <a:avLst/>
+          </a:prstGeom>
+          <a:noFill/>
+        </p:spPr>
+        <p:txBody>
+          <a:bodyPr wrap="square">
+            <a:spAutoFit/>
+          </a:bodyPr>
+          <a:lstStyle/>
+          <a:p>
+            <a:pPr algn="l"/>
+            <a:r>
+              <a:rPr sz="1600" b="1">
+                <a:solidFill>
+                  <a:srgbClr val="2DD4BF"/>
+                </a:solidFill>
+                <a:latin typeface="Aptos"/>
+              </a:rPr>
+              <a:t>Frontend checks</a:t>
+            </a:r>
+          </a:p>
+        </p:txBody>
+      </p:sp>
+      <p:sp>
+        <p:nvSpPr>
+          <p:cNvPr id="9" name="TextBox 8"/>
+          <p:cNvSpPr txBox="1"/>
+          <p:nvPr/>
+        </p:nvSpPr>
+        <p:spPr>
+          <a:xfrm>
+            <a:off x="4572000" y="2194560"/>
+            <a:ext cx="3108960" cy="2743200"/>
+          </a:xfrm>
+          <a:prstGeom prst="rect">
+            <a:avLst/>
+          </a:prstGeom>
+          <a:noFill/>
+        </p:spPr>
+        <p:txBody>
+          <a:bodyPr wrap="square">
+            <a:spAutoFit/>
+          </a:bodyPr>
+          <a:lstStyle/>
+          <a:p>
+            <a:pPr algn="l"/>
+            <a:r>
+              <a:rPr sz="1200" b="0">
+                <a:solidFill>
+                  <a:srgbClr val="E5EDF7"/>
+                </a:solidFill>
+                <a:latin typeface="Aptos"/>
+              </a:rPr>
+              <a:t>Production build
+16 generated routes
+Accessible labels and focus states
+Responsive landing/auth flows
+Reduced-motion support</a:t>
+            </a:r>
+          </a:p>
+        </p:txBody>
+      </p:sp>
+      <p:sp>
+        <p:nvSpPr>
+          <p:cNvPr id="10" name="Rounded Rectangle 9"/>
+          <p:cNvSpPr/>
+          <p:nvPr/>
+        </p:nvSpPr>
+        <p:spPr>
+          <a:xfrm>
+            <a:off x="8092440" y="1600200"/>
+            <a:ext cx="3474720" cy="3474720"/>
+          </a:xfrm>
+          <a:prstGeom prst="roundRect">
+            <a:avLst/>
+          </a:prstGeom>
+          <a:solidFill>
+            <a:srgbClr val="111A2D"/>
+          </a:solidFill>
+          <a:ln>
+            <a:solidFill>
+              <a:srgbClr val="2D3A52"/>
+            </a:solidFill>
+          </a:ln>
+        </p:spPr>
+        <p:style>
+          <a:lnRef idx="1">
+            <a:schemeClr val="accent1"/>
+          </a:lnRef>
+          <a:fillRef idx="3">
+            <a:schemeClr val="accent1"/>
+          </a:fillRef>
+          <a:effectRef idx="2">
+            <a:schemeClr val="accent1"/>
+          </a:effectRef>
+          <a:fontRef idx="minor">
+            <a:schemeClr val="lt1"/>
+          </a:fontRef>
+        </p:style>
+        <p:txBody>
+          <a:bodyPr rtlCol="0" anchor="ctr"/>
+          <a:lstStyle/>
+          <a:p>
+            <a:pPr algn="ctr"/>
+          </a:p>
+        </p:txBody>
+      </p:sp>
+      <p:sp>
+        <p:nvSpPr>
+          <p:cNvPr id="11" name="TextBox 10"/>
+          <p:cNvSpPr txBox="1"/>
+          <p:nvPr/>
+        </p:nvSpPr>
+        <p:spPr>
+          <a:xfrm>
+            <a:off x="8275319" y="1764792"/>
+            <a:ext cx="3108960" cy="320040"/>
+          </a:xfrm>
+          <a:prstGeom prst="rect">
+            <a:avLst/>
+          </a:prstGeom>
+          <a:noFill/>
+        </p:spPr>
+        <p:txBody>
+          <a:bodyPr wrap="square">
+            <a:spAutoFit/>
+          </a:bodyPr>
+          <a:lstStyle/>
+          <a:p>
+            <a:pPr algn="l"/>
+            <a:r>
+              <a:rPr sz="1600" b="1">
+                <a:solidFill>
+                  <a:srgbClr val="2DD4BF"/>
+                </a:solidFill>
+                <a:latin typeface="Aptos"/>
+              </a:rPr>
+              <a:t>Operational checks</a:t>
+            </a:r>
+          </a:p>
+        </p:txBody>
+      </p:sp>
+      <p:sp>
+        <p:nvSpPr>
+          <p:cNvPr id="12" name="TextBox 11"/>
+          <p:cNvSpPr txBox="1"/>
+          <p:nvPr/>
+        </p:nvSpPr>
+        <p:spPr>
+          <a:xfrm>
+            <a:off x="8275319" y="2194560"/>
+            <a:ext cx="3108960" cy="2743200"/>
+          </a:xfrm>
+          <a:prstGeom prst="rect">
+            <a:avLst/>
+          </a:prstGeom>
+          <a:noFill/>
+        </p:spPr>
+        <p:txBody>
+          <a:bodyPr wrap="square">
+            <a:spAutoFit/>
+          </a:bodyPr>
+          <a:lstStyle/>
+          <a:p>
+            <a:pPr algn="l"/>
+            <a:r>
+              <a:rPr sz="1200" b="0">
+                <a:solidFill>
+                  <a:srgbClr val="E5EDF7"/>
+                </a:solidFill>
+                <a:latin typeface="Aptos"/>
+              </a:rPr>
+              <a:t>Health endpoint
+Strict CORS defaults
+Production reload disabled
+Generic user-facing failures
+Diff and presentation validation</a:t>
+            </a:r>
+          </a:p>
+        </p:txBody>
+      </p:sp>
+      <p:sp>
+        <p:nvSpPr>
+          <p:cNvPr id="13" name="TextBox 12"/>
+          <p:cNvSpPr txBox="1"/>
+          <p:nvPr/>
+        </p:nvSpPr>
+        <p:spPr>
+          <a:xfrm>
+            <a:off x="868680" y="5623560"/>
+            <a:ext cx="10424160" cy="320040"/>
+          </a:xfrm>
+          <a:prstGeom prst="rect">
+            <a:avLst/>
+          </a:prstGeom>
+          <a:noFill/>
+        </p:spPr>
+        <p:txBody>
+          <a:bodyPr wrap="square">
+            <a:spAutoFit/>
+          </a:bodyPr>
+          <a:lstStyle/>
+          <a:p>
+            <a:pPr algn="ctr"/>
+            <a:r>
+              <a:rPr sz="1400" b="0">
+                <a:solidFill>
+                  <a:srgbClr val="2DD4BF"/>
+                </a:solidFill>
+                <a:latin typeface="Aptos"/>
+              </a:rPr>
+              <a:t>The demo separates verified behavior from roadmap items so the jury can evaluate the working MVP honestly.</a:t>
             </a:r>
           </a:p>
         </p:txBody>
@@ -6877,6 +9084,1975 @@
                 <a:latin typeface="Aptos"/>
               </a:rPr>
               <a:t>A shared retrieval layer can expose another company's private information.</a:t>
+            </a:r>
+          </a:p>
+        </p:txBody>
+      </p:sp>
+    </p:spTree>
+  </p:cSld>
+  <p:clrMapOvr>
+    <a:masterClrMapping/>
+  </p:clrMapOvr>
+</p:sld>
+</file>
+
+<file path=ppt/slides/slide20.xml><?xml version="1.0" encoding="utf-8"?>
+<p:sld xmlns:a="http://schemas.openxmlformats.org/drawingml/2006/main" xmlns:p="http://schemas.openxmlformats.org/presentationml/2006/main" xmlns:r="http://schemas.openxmlformats.org/officeDocument/2006/relationships">
+  <p:cSld>
+    <p:bg>
+      <p:bgPr>
+        <a:solidFill>
+          <a:srgbClr val="0B1120"/>
+        </a:solidFill>
+        <a:effectLst/>
+      </p:bgPr>
+    </p:bg>
+    <p:spTree>
+      <p:nvGrpSpPr>
+        <p:cNvPr id="1" name=""/>
+        <p:cNvGrpSpPr/>
+        <p:nvPr/>
+      </p:nvGrpSpPr>
+      <p:grpSpPr/>
+      <p:sp>
+        <p:nvSpPr>
+          <p:cNvPr id="2" name="TextBox 1"/>
+          <p:cNvSpPr txBox="1"/>
+          <p:nvPr/>
+        </p:nvSpPr>
+        <p:spPr>
+          <a:xfrm>
+            <a:off x="594360" y="411480"/>
+            <a:ext cx="10972800" cy="502920"/>
+          </a:xfrm>
+          <a:prstGeom prst="rect">
+            <a:avLst/>
+          </a:prstGeom>
+          <a:noFill/>
+        </p:spPr>
+        <p:txBody>
+          <a:bodyPr wrap="square">
+            <a:spAutoFit/>
+          </a:bodyPr>
+          <a:lstStyle/>
+          <a:p>
+            <a:pPr algn="l"/>
+            <a:r>
+              <a:rPr sz="2800" b="1">
+                <a:solidFill>
+                  <a:srgbClr val="E5EDF7"/>
+                </a:solidFill>
+                <a:latin typeface="Aptos"/>
+              </a:rPr>
+              <a:t>Render deployment runbook</a:t>
+            </a:r>
+          </a:p>
+        </p:txBody>
+      </p:sp>
+      <p:sp>
+        <p:nvSpPr>
+          <p:cNvPr id="3" name="TextBox 2"/>
+          <p:cNvSpPr txBox="1"/>
+          <p:nvPr/>
+        </p:nvSpPr>
+        <p:spPr>
+          <a:xfrm>
+            <a:off x="621792" y="987552"/>
+            <a:ext cx="10789920" cy="320040"/>
+          </a:xfrm>
+          <a:prstGeom prst="rect">
+            <a:avLst/>
+          </a:prstGeom>
+          <a:noFill/>
+        </p:spPr>
+        <p:txBody>
+          <a:bodyPr wrap="square">
+            <a:spAutoFit/>
+          </a:bodyPr>
+          <a:lstStyle/>
+          <a:p>
+            <a:pPr algn="l"/>
+            <a:r>
+              <a:rPr sz="1200" b="0">
+                <a:solidFill>
+                  <a:srgbClr val="94A3B8"/>
+                </a:solidFill>
+                <a:latin typeface="Aptos"/>
+              </a:rPr>
+              <a:t>A repeatable path from the repository to a public demo environment.</a:t>
+            </a:r>
+          </a:p>
+        </p:txBody>
+      </p:sp>
+      <p:sp>
+        <p:nvSpPr>
+          <p:cNvPr id="4" name="TextBox 3"/>
+          <p:cNvSpPr txBox="1"/>
+          <p:nvPr/>
+        </p:nvSpPr>
+        <p:spPr>
+          <a:xfrm>
+            <a:off x="822960" y="1554480"/>
+            <a:ext cx="4846320" cy="411480"/>
+          </a:xfrm>
+          <a:prstGeom prst="rect">
+            <a:avLst/>
+          </a:prstGeom>
+          <a:noFill/>
+        </p:spPr>
+        <p:txBody>
+          <a:bodyPr wrap="square">
+            <a:spAutoFit/>
+          </a:bodyPr>
+          <a:lstStyle/>
+          <a:p>
+            <a:pPr algn="l"/>
+            <a:r>
+              <a:rPr sz="1900" b="1">
+                <a:solidFill>
+                  <a:srgbClr val="E5EDF7"/>
+                </a:solidFill>
+                <a:latin typeface="Aptos"/>
+              </a:rPr>
+              <a:t>1  Create Blueprint</a:t>
+            </a:r>
+          </a:p>
+        </p:txBody>
+      </p:sp>
+      <p:sp>
+        <p:nvSpPr>
+          <p:cNvPr id="5" name="TextBox 4"/>
+          <p:cNvSpPr txBox="1"/>
+          <p:nvPr/>
+        </p:nvSpPr>
+        <p:spPr>
+          <a:xfrm>
+            <a:off x="822960" y="1965960"/>
+            <a:ext cx="5029200" cy="320040"/>
+          </a:xfrm>
+          <a:prstGeom prst="rect">
+            <a:avLst/>
+          </a:prstGeom>
+          <a:noFill/>
+        </p:spPr>
+        <p:txBody>
+          <a:bodyPr wrap="square">
+            <a:spAutoFit/>
+          </a:bodyPr>
+          <a:lstStyle/>
+          <a:p>
+            <a:pPr algn="l"/>
+            <a:r>
+              <a:rPr sz="1400" b="0">
+                <a:solidFill>
+                  <a:srgbClr val="94A3B8"/>
+                </a:solidFill>
+                <a:latin typeface="Aptos"/>
+              </a:rPr>
+              <a:t>Select the repository and apply render.yaml.</a:t>
+            </a:r>
+          </a:p>
+        </p:txBody>
+      </p:sp>
+      <p:sp>
+        <p:nvSpPr>
+          <p:cNvPr id="6" name="TextBox 5"/>
+          <p:cNvSpPr txBox="1"/>
+          <p:nvPr/>
+        </p:nvSpPr>
+        <p:spPr>
+          <a:xfrm>
+            <a:off x="822960" y="2606040"/>
+            <a:ext cx="4846320" cy="411480"/>
+          </a:xfrm>
+          <a:prstGeom prst="rect">
+            <a:avLst/>
+          </a:prstGeom>
+          <a:noFill/>
+        </p:spPr>
+        <p:txBody>
+          <a:bodyPr wrap="square">
+            <a:spAutoFit/>
+          </a:bodyPr>
+          <a:lstStyle/>
+          <a:p>
+            <a:pPr algn="l"/>
+            <a:r>
+              <a:rPr sz="1900" b="1">
+                <a:solidFill>
+                  <a:srgbClr val="E5EDF7"/>
+                </a:solidFill>
+                <a:latin typeface="Aptos"/>
+              </a:rPr>
+              <a:t>2  Configure secrets</a:t>
+            </a:r>
+          </a:p>
+        </p:txBody>
+      </p:sp>
+      <p:sp>
+        <p:nvSpPr>
+          <p:cNvPr id="7" name="TextBox 6"/>
+          <p:cNvSpPr txBox="1"/>
+          <p:nvPr/>
+        </p:nvSpPr>
+        <p:spPr>
+          <a:xfrm>
+            <a:off x="822960" y="3017520"/>
+            <a:ext cx="5303520" cy="502920"/>
+          </a:xfrm>
+          <a:prstGeom prst="rect">
+            <a:avLst/>
+          </a:prstGeom>
+          <a:noFill/>
+        </p:spPr>
+        <p:txBody>
+          <a:bodyPr wrap="square">
+            <a:spAutoFit/>
+          </a:bodyPr>
+          <a:lstStyle/>
+          <a:p>
+            <a:pPr algn="l"/>
+            <a:r>
+              <a:rPr sz="1400" b="0">
+                <a:solidFill>
+                  <a:srgbClr val="94A3B8"/>
+                </a:solidFill>
+                <a:latin typeface="Aptos"/>
+              </a:rPr>
+              <a:t>DATABASE_URL, SECRET_KEY, CORS_ORIGINS, SMTP, and Telegram token.</a:t>
+            </a:r>
+          </a:p>
+        </p:txBody>
+      </p:sp>
+      <p:sp>
+        <p:nvSpPr>
+          <p:cNvPr id="8" name="TextBox 7"/>
+          <p:cNvSpPr txBox="1"/>
+          <p:nvPr/>
+        </p:nvSpPr>
+        <p:spPr>
+          <a:xfrm>
+            <a:off x="822960" y="3657600"/>
+            <a:ext cx="4846320" cy="411480"/>
+          </a:xfrm>
+          <a:prstGeom prst="rect">
+            <a:avLst/>
+          </a:prstGeom>
+          <a:noFill/>
+        </p:spPr>
+        <p:txBody>
+          <a:bodyPr wrap="square">
+            <a:spAutoFit/>
+          </a:bodyPr>
+          <a:lstStyle/>
+          <a:p>
+            <a:pPr algn="l"/>
+            <a:r>
+              <a:rPr sz="1900" b="1">
+                <a:solidFill>
+                  <a:srgbClr val="E5EDF7"/>
+                </a:solidFill>
+                <a:latin typeface="Aptos"/>
+              </a:rPr>
+              <a:t>3  Seed and verify</a:t>
+            </a:r>
+          </a:p>
+        </p:txBody>
+      </p:sp>
+      <p:sp>
+        <p:nvSpPr>
+          <p:cNvPr id="9" name="TextBox 8"/>
+          <p:cNvSpPr txBox="1"/>
+          <p:nvPr/>
+        </p:nvSpPr>
+        <p:spPr>
+          <a:xfrm>
+            <a:off x="822960" y="4069080"/>
+            <a:ext cx="5486400" cy="640080"/>
+          </a:xfrm>
+          <a:prstGeom prst="rect">
+            <a:avLst/>
+          </a:prstGeom>
+          <a:noFill/>
+        </p:spPr>
+        <p:txBody>
+          <a:bodyPr wrap="square">
+            <a:spAutoFit/>
+          </a:bodyPr>
+          <a:lstStyle/>
+          <a:p>
+            <a:pPr algn="l"/>
+            <a:r>
+              <a:rPr sz="1400" b="0">
+                <a:solidFill>
+                  <a:srgbClr val="94A3B8"/>
+                </a:solidFill>
+                <a:latin typeface="Aptos"/>
+              </a:rPr>
+              <a:t>Run the explicit jury seed command, then test health, login, upload, chat, and logs.</a:t>
+            </a:r>
+          </a:p>
+        </p:txBody>
+      </p:sp>
+      <p:sp>
+        <p:nvSpPr>
+          <p:cNvPr id="10" name="Rounded Rectangle 9"/>
+          <p:cNvSpPr/>
+          <p:nvPr/>
+        </p:nvSpPr>
+        <p:spPr>
+          <a:xfrm>
+            <a:off x="6675120" y="1554480"/>
+            <a:ext cx="4754880" cy="3383280"/>
+          </a:xfrm>
+          <a:prstGeom prst="roundRect">
+            <a:avLst/>
+          </a:prstGeom>
+          <a:solidFill>
+            <a:srgbClr val="111A2D"/>
+          </a:solidFill>
+          <a:ln>
+            <a:solidFill>
+              <a:srgbClr val="2D3A52"/>
+            </a:solidFill>
+          </a:ln>
+        </p:spPr>
+        <p:style>
+          <a:lnRef idx="1">
+            <a:schemeClr val="accent1"/>
+          </a:lnRef>
+          <a:fillRef idx="3">
+            <a:schemeClr val="accent1"/>
+          </a:fillRef>
+          <a:effectRef idx="2">
+            <a:schemeClr val="accent1"/>
+          </a:effectRef>
+          <a:fontRef idx="minor">
+            <a:schemeClr val="lt1"/>
+          </a:fontRef>
+        </p:style>
+        <p:txBody>
+          <a:bodyPr rtlCol="0" anchor="ctr"/>
+          <a:lstStyle/>
+          <a:p>
+            <a:pPr algn="ctr"/>
+          </a:p>
+        </p:txBody>
+      </p:sp>
+      <p:sp>
+        <p:nvSpPr>
+          <p:cNvPr id="11" name="TextBox 10"/>
+          <p:cNvSpPr txBox="1"/>
+          <p:nvPr/>
+        </p:nvSpPr>
+        <p:spPr>
+          <a:xfrm>
+            <a:off x="6858000" y="1719072"/>
+            <a:ext cx="4389120" cy="320040"/>
+          </a:xfrm>
+          <a:prstGeom prst="rect">
+            <a:avLst/>
+          </a:prstGeom>
+          <a:noFill/>
+        </p:spPr>
+        <p:txBody>
+          <a:bodyPr wrap="square">
+            <a:spAutoFit/>
+          </a:bodyPr>
+          <a:lstStyle/>
+          <a:p>
+            <a:pPr algn="l"/>
+            <a:r>
+              <a:rPr sz="1600" b="1">
+                <a:solidFill>
+                  <a:srgbClr val="2DD4BF"/>
+                </a:solidFill>
+                <a:latin typeface="Aptos"/>
+              </a:rPr>
+              <a:t>Production checklist</a:t>
+            </a:r>
+          </a:p>
+        </p:txBody>
+      </p:sp>
+      <p:sp>
+        <p:nvSpPr>
+          <p:cNvPr id="12" name="TextBox 11"/>
+          <p:cNvSpPr txBox="1"/>
+          <p:nvPr/>
+        </p:nvSpPr>
+        <p:spPr>
+          <a:xfrm>
+            <a:off x="6858000" y="2148840"/>
+            <a:ext cx="4389120" cy="2651760"/>
+          </a:xfrm>
+          <a:prstGeom prst="rect">
+            <a:avLst/>
+          </a:prstGeom>
+          <a:noFill/>
+        </p:spPr>
+        <p:txBody>
+          <a:bodyPr wrap="square">
+            <a:spAutoFit/>
+          </a:bodyPr>
+          <a:lstStyle/>
+          <a:p>
+            <a:pPr algn="l"/>
+            <a:r>
+              <a:rPr sz="1200" b="0">
+                <a:solidFill>
+                  <a:srgbClr val="E5EDF7"/>
+                </a:solidFill>
+                <a:latin typeface="Aptos"/>
+              </a:rPr>
+              <a:t>Frontend URL added to backend CORS
+Managed PostgreSQL connected
+Persistent file storage selected
+SMTP delivery verified
+Secrets stored in Render, not Git
+Worker health and logs monitored</a:t>
+            </a:r>
+          </a:p>
+        </p:txBody>
+      </p:sp>
+      <p:sp>
+        <p:nvSpPr>
+          <p:cNvPr id="13" name="TextBox 12"/>
+          <p:cNvSpPr txBox="1"/>
+          <p:nvPr/>
+        </p:nvSpPr>
+        <p:spPr>
+          <a:xfrm>
+            <a:off x="822960" y="5669280"/>
+            <a:ext cx="10515600" cy="320040"/>
+          </a:xfrm>
+          <a:prstGeom prst="rect">
+            <a:avLst/>
+          </a:prstGeom>
+          <a:noFill/>
+        </p:spPr>
+        <p:txBody>
+          <a:bodyPr wrap="square">
+            <a:spAutoFit/>
+          </a:bodyPr>
+          <a:lstStyle/>
+          <a:p>
+            <a:pPr algn="ctr"/>
+            <a:r>
+              <a:rPr sz="1400" b="0">
+                <a:solidFill>
+                  <a:srgbClr val="2DD4BF"/>
+                </a:solidFill>
+                <a:latin typeface="Aptos"/>
+              </a:rPr>
+              <a:t>Deployment is an operator-controlled step; no paid or irreversible action is performed by the application.</a:t>
+            </a:r>
+          </a:p>
+        </p:txBody>
+      </p:sp>
+    </p:spTree>
+  </p:cSld>
+  <p:clrMapOvr>
+    <a:masterClrMapping/>
+  </p:clrMapOvr>
+</p:sld>
+</file>
+
+<file path=ppt/slides/slide21.xml><?xml version="1.0" encoding="utf-8"?>
+<p:sld xmlns:a="http://schemas.openxmlformats.org/drawingml/2006/main" xmlns:p="http://schemas.openxmlformats.org/presentationml/2006/main" xmlns:r="http://schemas.openxmlformats.org/officeDocument/2006/relationships">
+  <p:cSld>
+    <p:bg>
+      <p:bgPr>
+        <a:solidFill>
+          <a:srgbClr val="0B1120"/>
+        </a:solidFill>
+        <a:effectLst/>
+      </p:bgPr>
+    </p:bg>
+    <p:spTree>
+      <p:nvGrpSpPr>
+        <p:cNvPr id="1" name=""/>
+        <p:cNvGrpSpPr/>
+        <p:nvPr/>
+      </p:nvGrpSpPr>
+      <p:grpSpPr/>
+      <p:sp>
+        <p:nvSpPr>
+          <p:cNvPr id="2" name="TextBox 1"/>
+          <p:cNvSpPr txBox="1"/>
+          <p:nvPr/>
+        </p:nvSpPr>
+        <p:spPr>
+          <a:xfrm>
+            <a:off x="594360" y="411480"/>
+            <a:ext cx="10972800" cy="502920"/>
+          </a:xfrm>
+          <a:prstGeom prst="rect">
+            <a:avLst/>
+          </a:prstGeom>
+          <a:noFill/>
+        </p:spPr>
+        <p:txBody>
+          <a:bodyPr wrap="square">
+            <a:spAutoFit/>
+          </a:bodyPr>
+          <a:lstStyle/>
+          <a:p>
+            <a:pPr algn="l"/>
+            <a:r>
+              <a:rPr sz="2800" b="1">
+                <a:solidFill>
+                  <a:srgbClr val="E5EDF7"/>
+                </a:solidFill>
+                <a:latin typeface="Aptos"/>
+              </a:rPr>
+              <a:t>Risks and mitigations</a:t>
+            </a:r>
+          </a:p>
+        </p:txBody>
+      </p:sp>
+      <p:sp>
+        <p:nvSpPr>
+          <p:cNvPr id="3" name="TextBox 2"/>
+          <p:cNvSpPr txBox="1"/>
+          <p:nvPr/>
+        </p:nvSpPr>
+        <p:spPr>
+          <a:xfrm>
+            <a:off x="621792" y="987552"/>
+            <a:ext cx="10789920" cy="320040"/>
+          </a:xfrm>
+          <a:prstGeom prst="rect">
+            <a:avLst/>
+          </a:prstGeom>
+          <a:noFill/>
+        </p:spPr>
+        <p:txBody>
+          <a:bodyPr wrap="square">
+            <a:spAutoFit/>
+          </a:bodyPr>
+          <a:lstStyle/>
+          <a:p>
+            <a:pPr algn="l"/>
+            <a:r>
+              <a:rPr sz="1200" b="0">
+                <a:solidFill>
+                  <a:srgbClr val="94A3B8"/>
+                </a:solidFill>
+                <a:latin typeface="Aptos"/>
+              </a:rPr>
+              <a:t>The design acknowledges what can fail and how the platform responds.</a:t>
+            </a:r>
+          </a:p>
+        </p:txBody>
+      </p:sp>
+      <p:sp>
+        <p:nvSpPr>
+          <p:cNvPr id="4" name="Rounded Rectangle 3"/>
+          <p:cNvSpPr/>
+          <p:nvPr/>
+        </p:nvSpPr>
+        <p:spPr>
+          <a:xfrm>
+            <a:off x="685800" y="1600200"/>
+            <a:ext cx="3474720" cy="3520440"/>
+          </a:xfrm>
+          <a:prstGeom prst="roundRect">
+            <a:avLst/>
+          </a:prstGeom>
+          <a:solidFill>
+            <a:srgbClr val="111A2D"/>
+          </a:solidFill>
+          <a:ln>
+            <a:solidFill>
+              <a:srgbClr val="2D3A52"/>
+            </a:solidFill>
+          </a:ln>
+        </p:spPr>
+        <p:style>
+          <a:lnRef idx="1">
+            <a:schemeClr val="accent1"/>
+          </a:lnRef>
+          <a:fillRef idx="3">
+            <a:schemeClr val="accent1"/>
+          </a:fillRef>
+          <a:effectRef idx="2">
+            <a:schemeClr val="accent1"/>
+          </a:effectRef>
+          <a:fontRef idx="minor">
+            <a:schemeClr val="lt1"/>
+          </a:fontRef>
+        </p:style>
+        <p:txBody>
+          <a:bodyPr rtlCol="0" anchor="ctr"/>
+          <a:lstStyle/>
+          <a:p>
+            <a:pPr algn="ctr"/>
+          </a:p>
+        </p:txBody>
+      </p:sp>
+      <p:sp>
+        <p:nvSpPr>
+          <p:cNvPr id="5" name="TextBox 4"/>
+          <p:cNvSpPr txBox="1"/>
+          <p:nvPr/>
+        </p:nvSpPr>
+        <p:spPr>
+          <a:xfrm>
+            <a:off x="868680" y="1764792"/>
+            <a:ext cx="3108960" cy="320040"/>
+          </a:xfrm>
+          <a:prstGeom prst="rect">
+            <a:avLst/>
+          </a:prstGeom>
+          <a:noFill/>
+        </p:spPr>
+        <p:txBody>
+          <a:bodyPr wrap="square">
+            <a:spAutoFit/>
+          </a:bodyPr>
+          <a:lstStyle/>
+          <a:p>
+            <a:pPr algn="l"/>
+            <a:r>
+              <a:rPr sz="1600" b="1">
+                <a:solidFill>
+                  <a:srgbClr val="2DD4BF"/>
+                </a:solidFill>
+                <a:latin typeface="Aptos"/>
+              </a:rPr>
+              <a:t>Hallucination risk</a:t>
+            </a:r>
+          </a:p>
+        </p:txBody>
+      </p:sp>
+      <p:sp>
+        <p:nvSpPr>
+          <p:cNvPr id="6" name="TextBox 5"/>
+          <p:cNvSpPr txBox="1"/>
+          <p:nvPr/>
+        </p:nvSpPr>
+        <p:spPr>
+          <a:xfrm>
+            <a:off x="868680" y="2194560"/>
+            <a:ext cx="3108960" cy="2788920"/>
+          </a:xfrm>
+          <a:prstGeom prst="rect">
+            <a:avLst/>
+          </a:prstGeom>
+          <a:noFill/>
+        </p:spPr>
+        <p:txBody>
+          <a:bodyPr wrap="square">
+            <a:spAutoFit/>
+          </a:bodyPr>
+          <a:lstStyle/>
+          <a:p>
+            <a:pPr algn="l"/>
+            <a:r>
+              <a:rPr sz="1200" b="0">
+                <a:solidFill>
+                  <a:srgbClr val="E5EDF7"/>
+                </a:solidFill>
+                <a:latin typeface="Aptos"/>
+              </a:rPr>
+              <a:t>Mitigation: tenant-scoped retrieval, grounded prompts, citations, and explicit out-of-domain refusal.</a:t>
+            </a:r>
+          </a:p>
+        </p:txBody>
+      </p:sp>
+      <p:sp>
+        <p:nvSpPr>
+          <p:cNvPr id="7" name="Rounded Rectangle 6"/>
+          <p:cNvSpPr/>
+          <p:nvPr/>
+        </p:nvSpPr>
+        <p:spPr>
+          <a:xfrm>
+            <a:off x="4389120" y="1600200"/>
+            <a:ext cx="3474720" cy="3520440"/>
+          </a:xfrm>
+          <a:prstGeom prst="roundRect">
+            <a:avLst/>
+          </a:prstGeom>
+          <a:solidFill>
+            <a:srgbClr val="111A2D"/>
+          </a:solidFill>
+          <a:ln>
+            <a:solidFill>
+              <a:srgbClr val="2D3A52"/>
+            </a:solidFill>
+          </a:ln>
+        </p:spPr>
+        <p:style>
+          <a:lnRef idx="1">
+            <a:schemeClr val="accent1"/>
+          </a:lnRef>
+          <a:fillRef idx="3">
+            <a:schemeClr val="accent1"/>
+          </a:fillRef>
+          <a:effectRef idx="2">
+            <a:schemeClr val="accent1"/>
+          </a:effectRef>
+          <a:fontRef idx="minor">
+            <a:schemeClr val="lt1"/>
+          </a:fontRef>
+        </p:style>
+        <p:txBody>
+          <a:bodyPr rtlCol="0" anchor="ctr"/>
+          <a:lstStyle/>
+          <a:p>
+            <a:pPr algn="ctr"/>
+          </a:p>
+        </p:txBody>
+      </p:sp>
+      <p:sp>
+        <p:nvSpPr>
+          <p:cNvPr id="8" name="TextBox 7"/>
+          <p:cNvSpPr txBox="1"/>
+          <p:nvPr/>
+        </p:nvSpPr>
+        <p:spPr>
+          <a:xfrm>
+            <a:off x="4572000" y="1764792"/>
+            <a:ext cx="3108960" cy="320040"/>
+          </a:xfrm>
+          <a:prstGeom prst="rect">
+            <a:avLst/>
+          </a:prstGeom>
+          <a:noFill/>
+        </p:spPr>
+        <p:txBody>
+          <a:bodyPr wrap="square">
+            <a:spAutoFit/>
+          </a:bodyPr>
+          <a:lstStyle/>
+          <a:p>
+            <a:pPr algn="l"/>
+            <a:r>
+              <a:rPr sz="1600" b="1">
+                <a:solidFill>
+                  <a:srgbClr val="2DD4BF"/>
+                </a:solidFill>
+                <a:latin typeface="Aptos"/>
+              </a:rPr>
+              <a:t>Data leakage risk</a:t>
+            </a:r>
+          </a:p>
+        </p:txBody>
+      </p:sp>
+      <p:sp>
+        <p:nvSpPr>
+          <p:cNvPr id="9" name="TextBox 8"/>
+          <p:cNvSpPr txBox="1"/>
+          <p:nvPr/>
+        </p:nvSpPr>
+        <p:spPr>
+          <a:xfrm>
+            <a:off x="4572000" y="2194560"/>
+            <a:ext cx="3108960" cy="2788920"/>
+          </a:xfrm>
+          <a:prstGeom prst="rect">
+            <a:avLst/>
+          </a:prstGeom>
+          <a:noFill/>
+        </p:spPr>
+        <p:txBody>
+          <a:bodyPr wrap="square">
+            <a:spAutoFit/>
+          </a:bodyPr>
+          <a:lstStyle/>
+          <a:p>
+            <a:pPr algn="l"/>
+            <a:r>
+              <a:rPr sz="1200" b="0">
+                <a:solidFill>
+                  <a:srgbClr val="E5EDF7"/>
+                </a:solidFill>
+                <a:latin typeface="Aptos"/>
+              </a:rPr>
+              <a:t>Mitigation: server-side tenant filters, hidden 404 responses, role guards, audit events, and IDOR simulation.</a:t>
+            </a:r>
+          </a:p>
+        </p:txBody>
+      </p:sp>
+      <p:sp>
+        <p:nvSpPr>
+          <p:cNvPr id="10" name="Rounded Rectangle 9"/>
+          <p:cNvSpPr/>
+          <p:nvPr/>
+        </p:nvSpPr>
+        <p:spPr>
+          <a:xfrm>
+            <a:off x="8092440" y="1600200"/>
+            <a:ext cx="3474720" cy="3520440"/>
+          </a:xfrm>
+          <a:prstGeom prst="roundRect">
+            <a:avLst/>
+          </a:prstGeom>
+          <a:solidFill>
+            <a:srgbClr val="111A2D"/>
+          </a:solidFill>
+          <a:ln>
+            <a:solidFill>
+              <a:srgbClr val="2D3A52"/>
+            </a:solidFill>
+          </a:ln>
+        </p:spPr>
+        <p:style>
+          <a:lnRef idx="1">
+            <a:schemeClr val="accent1"/>
+          </a:lnRef>
+          <a:fillRef idx="3">
+            <a:schemeClr val="accent1"/>
+          </a:fillRef>
+          <a:effectRef idx="2">
+            <a:schemeClr val="accent1"/>
+          </a:effectRef>
+          <a:fontRef idx="minor">
+            <a:schemeClr val="lt1"/>
+          </a:fontRef>
+        </p:style>
+        <p:txBody>
+          <a:bodyPr rtlCol="0" anchor="ctr"/>
+          <a:lstStyle/>
+          <a:p>
+            <a:pPr algn="ctr"/>
+          </a:p>
+        </p:txBody>
+      </p:sp>
+      <p:sp>
+        <p:nvSpPr>
+          <p:cNvPr id="11" name="TextBox 10"/>
+          <p:cNvSpPr txBox="1"/>
+          <p:nvPr/>
+        </p:nvSpPr>
+        <p:spPr>
+          <a:xfrm>
+            <a:off x="8275319" y="1764792"/>
+            <a:ext cx="3108960" cy="320040"/>
+          </a:xfrm>
+          <a:prstGeom prst="rect">
+            <a:avLst/>
+          </a:prstGeom>
+          <a:noFill/>
+        </p:spPr>
+        <p:txBody>
+          <a:bodyPr wrap="square">
+            <a:spAutoFit/>
+          </a:bodyPr>
+          <a:lstStyle/>
+          <a:p>
+            <a:pPr algn="l"/>
+            <a:r>
+              <a:rPr sz="1600" b="1">
+                <a:solidFill>
+                  <a:srgbClr val="2DD4BF"/>
+                </a:solidFill>
+                <a:latin typeface="Aptos"/>
+              </a:rPr>
+              <a:t>Production scale risk</a:t>
+            </a:r>
+          </a:p>
+        </p:txBody>
+      </p:sp>
+      <p:sp>
+        <p:nvSpPr>
+          <p:cNvPr id="12" name="TextBox 11"/>
+          <p:cNvSpPr txBox="1"/>
+          <p:nvPr/>
+        </p:nvSpPr>
+        <p:spPr>
+          <a:xfrm>
+            <a:off x="8275319" y="2194560"/>
+            <a:ext cx="3108960" cy="2788920"/>
+          </a:xfrm>
+          <a:prstGeom prst="rect">
+            <a:avLst/>
+          </a:prstGeom>
+          <a:noFill/>
+        </p:spPr>
+        <p:txBody>
+          <a:bodyPr wrap="square">
+            <a:spAutoFit/>
+          </a:bodyPr>
+          <a:lstStyle/>
+          <a:p>
+            <a:pPr algn="l"/>
+            <a:r>
+              <a:rPr sz="1200" b="0">
+                <a:solidFill>
+                  <a:srgbClr val="E5EDF7"/>
+                </a:solidFill>
+                <a:latin typeface="Aptos"/>
+              </a:rPr>
+              <a:t>Mitigation roadmap: Alembic migrations, object storage, async workers, OCR, rate limits, and managed observability.</a:t>
+            </a:r>
+          </a:p>
+        </p:txBody>
+      </p:sp>
+      <p:sp>
+        <p:nvSpPr>
+          <p:cNvPr id="13" name="TextBox 12"/>
+          <p:cNvSpPr txBox="1"/>
+          <p:nvPr/>
+        </p:nvSpPr>
+        <p:spPr>
+          <a:xfrm>
+            <a:off x="868680" y="5623560"/>
+            <a:ext cx="10424160" cy="320040"/>
+          </a:xfrm>
+          <a:prstGeom prst="rect">
+            <a:avLst/>
+          </a:prstGeom>
+          <a:noFill/>
+        </p:spPr>
+        <p:txBody>
+          <a:bodyPr wrap="square">
+            <a:spAutoFit/>
+          </a:bodyPr>
+          <a:lstStyle/>
+          <a:p>
+            <a:pPr algn="ctr"/>
+            <a:r>
+              <a:rPr sz="1400" b="0">
+                <a:solidFill>
+                  <a:srgbClr val="2DD4BF"/>
+                </a:solidFill>
+                <a:latin typeface="Aptos"/>
+              </a:rPr>
+              <a:t>Security is treated as a product feature and an observable operating process, not a UI promise.</a:t>
+            </a:r>
+          </a:p>
+        </p:txBody>
+      </p:sp>
+    </p:spTree>
+  </p:cSld>
+  <p:clrMapOvr>
+    <a:masterClrMapping/>
+  </p:clrMapOvr>
+</p:sld>
+</file>
+
+<file path=ppt/slides/slide22.xml><?xml version="1.0" encoding="utf-8"?>
+<p:sld xmlns:a="http://schemas.openxmlformats.org/drawingml/2006/main" xmlns:p="http://schemas.openxmlformats.org/presentationml/2006/main" xmlns:r="http://schemas.openxmlformats.org/officeDocument/2006/relationships">
+  <p:cSld>
+    <p:bg>
+      <p:bgPr>
+        <a:solidFill>
+          <a:srgbClr val="0B1120"/>
+        </a:solidFill>
+        <a:effectLst/>
+      </p:bgPr>
+    </p:bg>
+    <p:spTree>
+      <p:nvGrpSpPr>
+        <p:cNvPr id="1" name=""/>
+        <p:cNvGrpSpPr/>
+        <p:nvPr/>
+      </p:nvGrpSpPr>
+      <p:grpSpPr/>
+      <p:sp>
+        <p:nvSpPr>
+          <p:cNvPr id="2" name="TextBox 1"/>
+          <p:cNvSpPr txBox="1"/>
+          <p:nvPr/>
+        </p:nvSpPr>
+        <p:spPr>
+          <a:xfrm>
+            <a:off x="594360" y="411480"/>
+            <a:ext cx="10972800" cy="502920"/>
+          </a:xfrm>
+          <a:prstGeom prst="rect">
+            <a:avLst/>
+          </a:prstGeom>
+          <a:noFill/>
+        </p:spPr>
+        <p:txBody>
+          <a:bodyPr wrap="square">
+            <a:spAutoFit/>
+          </a:bodyPr>
+          <a:lstStyle/>
+          <a:p>
+            <a:pPr algn="l"/>
+            <a:r>
+              <a:rPr sz="2800" b="1">
+                <a:solidFill>
+                  <a:srgbClr val="E5EDF7"/>
+                </a:solidFill>
+                <a:latin typeface="Aptos"/>
+              </a:rPr>
+              <a:t>Jury questions: concise answers</a:t>
+            </a:r>
+          </a:p>
+        </p:txBody>
+      </p:sp>
+      <p:sp>
+        <p:nvSpPr>
+          <p:cNvPr id="3" name="TextBox 2"/>
+          <p:cNvSpPr txBox="1"/>
+          <p:nvPr/>
+        </p:nvSpPr>
+        <p:spPr>
+          <a:xfrm>
+            <a:off x="621792" y="987552"/>
+            <a:ext cx="10789920" cy="320040"/>
+          </a:xfrm>
+          <a:prstGeom prst="rect">
+            <a:avLst/>
+          </a:prstGeom>
+          <a:noFill/>
+        </p:spPr>
+        <p:txBody>
+          <a:bodyPr wrap="square">
+            <a:spAutoFit/>
+          </a:bodyPr>
+          <a:lstStyle/>
+          <a:p>
+            <a:pPr algn="l"/>
+            <a:r>
+              <a:rPr sz="1200" b="0">
+                <a:solidFill>
+                  <a:srgbClr val="94A3B8"/>
+                </a:solidFill>
+                <a:latin typeface="Aptos"/>
+              </a:rPr>
+              <a:t>Use this slide as a speaker prompt during evaluation.</a:t>
+            </a:r>
+          </a:p>
+        </p:txBody>
+      </p:sp>
+      <p:sp>
+        <p:nvSpPr>
+          <p:cNvPr id="4" name="Rounded Rectangle 3"/>
+          <p:cNvSpPr/>
+          <p:nvPr/>
+        </p:nvSpPr>
+        <p:spPr>
+          <a:xfrm>
+            <a:off x="594360" y="1554480"/>
+            <a:ext cx="2606040" cy="3657600"/>
+          </a:xfrm>
+          <a:prstGeom prst="roundRect">
+            <a:avLst/>
+          </a:prstGeom>
+          <a:solidFill>
+            <a:srgbClr val="111A2D"/>
+          </a:solidFill>
+          <a:ln>
+            <a:solidFill>
+              <a:srgbClr val="2D3A52"/>
+            </a:solidFill>
+          </a:ln>
+        </p:spPr>
+        <p:style>
+          <a:lnRef idx="1">
+            <a:schemeClr val="accent1"/>
+          </a:lnRef>
+          <a:fillRef idx="3">
+            <a:schemeClr val="accent1"/>
+          </a:fillRef>
+          <a:effectRef idx="2">
+            <a:schemeClr val="accent1"/>
+          </a:effectRef>
+          <a:fontRef idx="minor">
+            <a:schemeClr val="lt1"/>
+          </a:fontRef>
+        </p:style>
+        <p:txBody>
+          <a:bodyPr rtlCol="0" anchor="ctr"/>
+          <a:lstStyle/>
+          <a:p>
+            <a:pPr algn="ctr"/>
+          </a:p>
+        </p:txBody>
+      </p:sp>
+      <p:sp>
+        <p:nvSpPr>
+          <p:cNvPr id="5" name="TextBox 4"/>
+          <p:cNvSpPr txBox="1"/>
+          <p:nvPr/>
+        </p:nvSpPr>
+        <p:spPr>
+          <a:xfrm>
+            <a:off x="777240" y="1719072"/>
+            <a:ext cx="2240280" cy="320040"/>
+          </a:xfrm>
+          <a:prstGeom prst="rect">
+            <a:avLst/>
+          </a:prstGeom>
+          <a:noFill/>
+        </p:spPr>
+        <p:txBody>
+          <a:bodyPr wrap="square">
+            <a:spAutoFit/>
+          </a:bodyPr>
+          <a:lstStyle/>
+          <a:p>
+            <a:pPr algn="l"/>
+            <a:r>
+              <a:rPr sz="1600" b="1">
+                <a:solidFill>
+                  <a:srgbClr val="2DD4BF"/>
+                </a:solidFill>
+                <a:latin typeface="Aptos"/>
+              </a:rPr>
+              <a:t>Why multi-tenant?</a:t>
+            </a:r>
+          </a:p>
+        </p:txBody>
+      </p:sp>
+      <p:sp>
+        <p:nvSpPr>
+          <p:cNvPr id="6" name="TextBox 5"/>
+          <p:cNvSpPr txBox="1"/>
+          <p:nvPr/>
+        </p:nvSpPr>
+        <p:spPr>
+          <a:xfrm>
+            <a:off x="777240" y="2148840"/>
+            <a:ext cx="2240280" cy="2926080"/>
+          </a:xfrm>
+          <a:prstGeom prst="rect">
+            <a:avLst/>
+          </a:prstGeom>
+          <a:noFill/>
+        </p:spPr>
+        <p:txBody>
+          <a:bodyPr wrap="square">
+            <a:spAutoFit/>
+          </a:bodyPr>
+          <a:lstStyle/>
+          <a:p>
+            <a:pPr algn="l"/>
+            <a:r>
+              <a:rPr sz="1200" b="0">
+                <a:solidFill>
+                  <a:srgbClr val="E5EDF7"/>
+                </a:solidFill>
+                <a:latin typeface="Aptos"/>
+              </a:rPr>
+              <a:t>A company assistant must be useful without mixing confidential workspaces. Tenant scope is enforced in backend queries.</a:t>
+            </a:r>
+          </a:p>
+        </p:txBody>
+      </p:sp>
+      <p:sp>
+        <p:nvSpPr>
+          <p:cNvPr id="7" name="Rounded Rectangle 6"/>
+          <p:cNvSpPr/>
+          <p:nvPr/>
+        </p:nvSpPr>
+        <p:spPr>
+          <a:xfrm>
+            <a:off x="3337560" y="1554480"/>
+            <a:ext cx="2606040" cy="3657600"/>
+          </a:xfrm>
+          <a:prstGeom prst="roundRect">
+            <a:avLst/>
+          </a:prstGeom>
+          <a:solidFill>
+            <a:srgbClr val="111A2D"/>
+          </a:solidFill>
+          <a:ln>
+            <a:solidFill>
+              <a:srgbClr val="2D3A52"/>
+            </a:solidFill>
+          </a:ln>
+        </p:spPr>
+        <p:style>
+          <a:lnRef idx="1">
+            <a:schemeClr val="accent1"/>
+          </a:lnRef>
+          <a:fillRef idx="3">
+            <a:schemeClr val="accent1"/>
+          </a:fillRef>
+          <a:effectRef idx="2">
+            <a:schemeClr val="accent1"/>
+          </a:effectRef>
+          <a:fontRef idx="minor">
+            <a:schemeClr val="lt1"/>
+          </a:fontRef>
+        </p:style>
+        <p:txBody>
+          <a:bodyPr rtlCol="0" anchor="ctr"/>
+          <a:lstStyle/>
+          <a:p>
+            <a:pPr algn="ctr"/>
+          </a:p>
+        </p:txBody>
+      </p:sp>
+      <p:sp>
+        <p:nvSpPr>
+          <p:cNvPr id="8" name="TextBox 7"/>
+          <p:cNvSpPr txBox="1"/>
+          <p:nvPr/>
+        </p:nvSpPr>
+        <p:spPr>
+          <a:xfrm>
+            <a:off x="3520440" y="1719072"/>
+            <a:ext cx="2240280" cy="320040"/>
+          </a:xfrm>
+          <a:prstGeom prst="rect">
+            <a:avLst/>
+          </a:prstGeom>
+          <a:noFill/>
+        </p:spPr>
+        <p:txBody>
+          <a:bodyPr wrap="square">
+            <a:spAutoFit/>
+          </a:bodyPr>
+          <a:lstStyle/>
+          <a:p>
+            <a:pPr algn="l"/>
+            <a:r>
+              <a:rPr sz="1600" b="1">
+                <a:solidFill>
+                  <a:srgbClr val="2DD4BF"/>
+                </a:solidFill>
+                <a:latin typeface="Aptos"/>
+              </a:rPr>
+              <a:t>Why RAG?</a:t>
+            </a:r>
+          </a:p>
+        </p:txBody>
+      </p:sp>
+      <p:sp>
+        <p:nvSpPr>
+          <p:cNvPr id="9" name="TextBox 8"/>
+          <p:cNvSpPr txBox="1"/>
+          <p:nvPr/>
+        </p:nvSpPr>
+        <p:spPr>
+          <a:xfrm>
+            <a:off x="3520440" y="2148840"/>
+            <a:ext cx="2240280" cy="2926080"/>
+          </a:xfrm>
+          <a:prstGeom prst="rect">
+            <a:avLst/>
+          </a:prstGeom>
+          <a:noFill/>
+        </p:spPr>
+        <p:txBody>
+          <a:bodyPr wrap="square">
+            <a:spAutoFit/>
+          </a:bodyPr>
+          <a:lstStyle/>
+          <a:p>
+            <a:pPr algn="l"/>
+            <a:r>
+              <a:rPr sz="1200" b="0">
+                <a:solidFill>
+                  <a:srgbClr val="E5EDF7"/>
+                </a:solidFill>
+                <a:latin typeface="Aptos"/>
+              </a:rPr>
+              <a:t>Company policies change. Retrieval grounds answers in the latest approved documents instead of model memory.</a:t>
+            </a:r>
+          </a:p>
+        </p:txBody>
+      </p:sp>
+      <p:sp>
+        <p:nvSpPr>
+          <p:cNvPr id="10" name="Rounded Rectangle 9"/>
+          <p:cNvSpPr/>
+          <p:nvPr/>
+        </p:nvSpPr>
+        <p:spPr>
+          <a:xfrm>
+            <a:off x="6080760" y="1554480"/>
+            <a:ext cx="2606040" cy="3657600"/>
+          </a:xfrm>
+          <a:prstGeom prst="roundRect">
+            <a:avLst/>
+          </a:prstGeom>
+          <a:solidFill>
+            <a:srgbClr val="111A2D"/>
+          </a:solidFill>
+          <a:ln>
+            <a:solidFill>
+              <a:srgbClr val="2D3A52"/>
+            </a:solidFill>
+          </a:ln>
+        </p:spPr>
+        <p:style>
+          <a:lnRef idx="1">
+            <a:schemeClr val="accent1"/>
+          </a:lnRef>
+          <a:fillRef idx="3">
+            <a:schemeClr val="accent1"/>
+          </a:fillRef>
+          <a:effectRef idx="2">
+            <a:schemeClr val="accent1"/>
+          </a:effectRef>
+          <a:fontRef idx="minor">
+            <a:schemeClr val="lt1"/>
+          </a:fontRef>
+        </p:style>
+        <p:txBody>
+          <a:bodyPr rtlCol="0" anchor="ctr"/>
+          <a:lstStyle/>
+          <a:p>
+            <a:pPr algn="ctr"/>
+          </a:p>
+        </p:txBody>
+      </p:sp>
+      <p:sp>
+        <p:nvSpPr>
+          <p:cNvPr id="11" name="TextBox 10"/>
+          <p:cNvSpPr txBox="1"/>
+          <p:nvPr/>
+        </p:nvSpPr>
+        <p:spPr>
+          <a:xfrm>
+            <a:off x="6263640" y="1719072"/>
+            <a:ext cx="2240280" cy="320040"/>
+          </a:xfrm>
+          <a:prstGeom prst="rect">
+            <a:avLst/>
+          </a:prstGeom>
+          <a:noFill/>
+        </p:spPr>
+        <p:txBody>
+          <a:bodyPr wrap="square">
+            <a:spAutoFit/>
+          </a:bodyPr>
+          <a:lstStyle/>
+          <a:p>
+            <a:pPr algn="l"/>
+            <a:r>
+              <a:rPr sz="1600" b="1">
+                <a:solidFill>
+                  <a:srgbClr val="2DD4BF"/>
+                </a:solidFill>
+                <a:latin typeface="Aptos"/>
+              </a:rPr>
+              <a:t>How do you prove security?</a:t>
+            </a:r>
+          </a:p>
+        </p:txBody>
+      </p:sp>
+      <p:sp>
+        <p:nvSpPr>
+          <p:cNvPr id="12" name="TextBox 11"/>
+          <p:cNvSpPr txBox="1"/>
+          <p:nvPr/>
+        </p:nvSpPr>
+        <p:spPr>
+          <a:xfrm>
+            <a:off x="6263640" y="2148840"/>
+            <a:ext cx="2240280" cy="2926080"/>
+          </a:xfrm>
+          <a:prstGeom prst="rect">
+            <a:avLst/>
+          </a:prstGeom>
+          <a:noFill/>
+        </p:spPr>
+        <p:txBody>
+          <a:bodyPr wrap="square">
+            <a:spAutoFit/>
+          </a:bodyPr>
+          <a:lstStyle/>
+          <a:p>
+            <a:pPr algn="l"/>
+            <a:r>
+              <a:rPr sz="1200" b="0">
+                <a:solidFill>
+                  <a:srgbClr val="E5EDF7"/>
+                </a:solidFill>
+                <a:latin typeface="Aptos"/>
+              </a:rPr>
+              <a:t>Run the IDOR simulator, observe 404 and zero leaked bytes, then inspect the audit event.</a:t>
+            </a:r>
+          </a:p>
+        </p:txBody>
+      </p:sp>
+      <p:sp>
+        <p:nvSpPr>
+          <p:cNvPr id="13" name="Rounded Rectangle 12"/>
+          <p:cNvSpPr/>
+          <p:nvPr/>
+        </p:nvSpPr>
+        <p:spPr>
+          <a:xfrm>
+            <a:off x="8823960" y="1554480"/>
+            <a:ext cx="2606040" cy="3657600"/>
+          </a:xfrm>
+          <a:prstGeom prst="roundRect">
+            <a:avLst/>
+          </a:prstGeom>
+          <a:solidFill>
+            <a:srgbClr val="111A2D"/>
+          </a:solidFill>
+          <a:ln>
+            <a:solidFill>
+              <a:srgbClr val="2D3A52"/>
+            </a:solidFill>
+          </a:ln>
+        </p:spPr>
+        <p:style>
+          <a:lnRef idx="1">
+            <a:schemeClr val="accent1"/>
+          </a:lnRef>
+          <a:fillRef idx="3">
+            <a:schemeClr val="accent1"/>
+          </a:fillRef>
+          <a:effectRef idx="2">
+            <a:schemeClr val="accent1"/>
+          </a:effectRef>
+          <a:fontRef idx="minor">
+            <a:schemeClr val="lt1"/>
+          </a:fontRef>
+        </p:style>
+        <p:txBody>
+          <a:bodyPr rtlCol="0" anchor="ctr"/>
+          <a:lstStyle/>
+          <a:p>
+            <a:pPr algn="ctr"/>
+          </a:p>
+        </p:txBody>
+      </p:sp>
+      <p:sp>
+        <p:nvSpPr>
+          <p:cNvPr id="14" name="TextBox 13"/>
+          <p:cNvSpPr txBox="1"/>
+          <p:nvPr/>
+        </p:nvSpPr>
+        <p:spPr>
+          <a:xfrm>
+            <a:off x="9006840" y="1719072"/>
+            <a:ext cx="2240280" cy="320040"/>
+          </a:xfrm>
+          <a:prstGeom prst="rect">
+            <a:avLst/>
+          </a:prstGeom>
+          <a:noFill/>
+        </p:spPr>
+        <p:txBody>
+          <a:bodyPr wrap="square">
+            <a:spAutoFit/>
+          </a:bodyPr>
+          <a:lstStyle/>
+          <a:p>
+            <a:pPr algn="l"/>
+            <a:r>
+              <a:rPr sz="1600" b="1">
+                <a:solidFill>
+                  <a:srgbClr val="2DD4BF"/>
+                </a:solidFill>
+                <a:latin typeface="Aptos"/>
+              </a:rPr>
+              <a:t>What is next?</a:t>
+            </a:r>
+          </a:p>
+        </p:txBody>
+      </p:sp>
+      <p:sp>
+        <p:nvSpPr>
+          <p:cNvPr id="15" name="TextBox 14"/>
+          <p:cNvSpPr txBox="1"/>
+          <p:nvPr/>
+        </p:nvSpPr>
+        <p:spPr>
+          <a:xfrm>
+            <a:off x="9006840" y="2148840"/>
+            <a:ext cx="2240280" cy="2926080"/>
+          </a:xfrm>
+          <a:prstGeom prst="rect">
+            <a:avLst/>
+          </a:prstGeom>
+          <a:noFill/>
+        </p:spPr>
+        <p:txBody>
+          <a:bodyPr wrap="square">
+            <a:spAutoFit/>
+          </a:bodyPr>
+          <a:lstStyle/>
+          <a:p>
+            <a:pPr algn="l"/>
+            <a:r>
+              <a:rPr sz="1200" b="0">
+                <a:solidFill>
+                  <a:srgbClr val="E5EDF7"/>
+                </a:solidFill>
+                <a:latin typeface="Aptos"/>
+              </a:rPr>
+              <a:t>Production migrations, storage, OCR, async processing, and verified Render rollout.</a:t>
+            </a:r>
+          </a:p>
+        </p:txBody>
+      </p:sp>
+    </p:spTree>
+  </p:cSld>
+  <p:clrMapOvr>
+    <a:masterClrMapping/>
+  </p:clrMapOvr>
+</p:sld>
+</file>
+
+<file path=ppt/slides/slide23.xml><?xml version="1.0" encoding="utf-8"?>
+<p:sld xmlns:a="http://schemas.openxmlformats.org/drawingml/2006/main" xmlns:p="http://schemas.openxmlformats.org/presentationml/2006/main" xmlns:r="http://schemas.openxmlformats.org/officeDocument/2006/relationships">
+  <p:cSld>
+    <p:bg>
+      <p:bgPr>
+        <a:solidFill>
+          <a:srgbClr val="0B1120"/>
+        </a:solidFill>
+        <a:effectLst/>
+      </p:bgPr>
+    </p:bg>
+    <p:spTree>
+      <p:nvGrpSpPr>
+        <p:cNvPr id="1" name=""/>
+        <p:cNvGrpSpPr/>
+        <p:nvPr/>
+      </p:nvGrpSpPr>
+      <p:grpSpPr/>
+      <p:sp>
+        <p:nvSpPr>
+          <p:cNvPr id="2" name="TextBox 1"/>
+          <p:cNvSpPr txBox="1"/>
+          <p:nvPr/>
+        </p:nvSpPr>
+        <p:spPr>
+          <a:xfrm>
+            <a:off x="594360" y="411480"/>
+            <a:ext cx="10972800" cy="502920"/>
+          </a:xfrm>
+          <a:prstGeom prst="rect">
+            <a:avLst/>
+          </a:prstGeom>
+          <a:noFill/>
+        </p:spPr>
+        <p:txBody>
+          <a:bodyPr wrap="square">
+            <a:spAutoFit/>
+          </a:bodyPr>
+          <a:lstStyle/>
+          <a:p>
+            <a:pPr algn="l"/>
+            <a:r>
+              <a:rPr sz="2800" b="1">
+                <a:solidFill>
+                  <a:srgbClr val="E5EDF7"/>
+                </a:solidFill>
+                <a:latin typeface="Aptos"/>
+              </a:rPr>
+              <a:t>Conclusion and roadmap</a:t>
+            </a:r>
+          </a:p>
+        </p:txBody>
+      </p:sp>
+      <p:sp>
+        <p:nvSpPr>
+          <p:cNvPr id="3" name="TextBox 2"/>
+          <p:cNvSpPr txBox="1"/>
+          <p:nvPr/>
+        </p:nvSpPr>
+        <p:spPr>
+          <a:xfrm>
+            <a:off x="621792" y="987552"/>
+            <a:ext cx="10789920" cy="320040"/>
+          </a:xfrm>
+          <a:prstGeom prst="rect">
+            <a:avLst/>
+          </a:prstGeom>
+          <a:noFill/>
+        </p:spPr>
+        <p:txBody>
+          <a:bodyPr wrap="square">
+            <a:spAutoFit/>
+          </a:bodyPr>
+          <a:lstStyle/>
+          <a:p>
+            <a:pPr algn="l"/>
+            <a:r>
+              <a:rPr sz="1200" b="0">
+                <a:solidFill>
+                  <a:srgbClr val="94A3B8"/>
+                </a:solidFill>
+                <a:latin typeface="Aptos"/>
+              </a:rPr>
+              <a:t>Secure foundations first; integrate only what can be verified.</a:t>
+            </a:r>
+          </a:p>
+        </p:txBody>
+      </p:sp>
+      <p:sp>
+        <p:nvSpPr>
+          <p:cNvPr id="4" name="Rounded Rectangle 3"/>
+          <p:cNvSpPr/>
+          <p:nvPr/>
+        </p:nvSpPr>
+        <p:spPr>
+          <a:xfrm>
+            <a:off x="685800" y="1645920"/>
+            <a:ext cx="3474720" cy="3291840"/>
+          </a:xfrm>
+          <a:prstGeom prst="roundRect">
+            <a:avLst/>
+          </a:prstGeom>
+          <a:solidFill>
+            <a:srgbClr val="111A2D"/>
+          </a:solidFill>
+          <a:ln>
+            <a:solidFill>
+              <a:srgbClr val="2D3A52"/>
+            </a:solidFill>
+          </a:ln>
+        </p:spPr>
+        <p:style>
+          <a:lnRef idx="1">
+            <a:schemeClr val="accent1"/>
+          </a:lnRef>
+          <a:fillRef idx="3">
+            <a:schemeClr val="accent1"/>
+          </a:fillRef>
+          <a:effectRef idx="2">
+            <a:schemeClr val="accent1"/>
+          </a:effectRef>
+          <a:fontRef idx="minor">
+            <a:schemeClr val="lt1"/>
+          </a:fontRef>
+        </p:style>
+        <p:txBody>
+          <a:bodyPr rtlCol="0" anchor="ctr"/>
+          <a:lstStyle/>
+          <a:p>
+            <a:pPr algn="ctr"/>
+          </a:p>
+        </p:txBody>
+      </p:sp>
+      <p:sp>
+        <p:nvSpPr>
+          <p:cNvPr id="5" name="TextBox 4"/>
+          <p:cNvSpPr txBox="1"/>
+          <p:nvPr/>
+        </p:nvSpPr>
+        <p:spPr>
+          <a:xfrm>
+            <a:off x="868680" y="1810512"/>
+            <a:ext cx="3108960" cy="320040"/>
+          </a:xfrm>
+          <a:prstGeom prst="rect">
+            <a:avLst/>
+          </a:prstGeom>
+          <a:noFill/>
+        </p:spPr>
+        <p:txBody>
+          <a:bodyPr wrap="square">
+            <a:spAutoFit/>
+          </a:bodyPr>
+          <a:lstStyle/>
+          <a:p>
+            <a:pPr algn="l"/>
+            <a:r>
+              <a:rPr sz="1600" b="1">
+                <a:solidFill>
+                  <a:srgbClr val="2DD4BF"/>
+                </a:solidFill>
+                <a:latin typeface="Aptos"/>
+              </a:rPr>
+              <a:t>Now</a:t>
+            </a:r>
+          </a:p>
+        </p:txBody>
+      </p:sp>
+      <p:sp>
+        <p:nvSpPr>
+          <p:cNvPr id="6" name="TextBox 5"/>
+          <p:cNvSpPr txBox="1"/>
+          <p:nvPr/>
+        </p:nvSpPr>
+        <p:spPr>
+          <a:xfrm>
+            <a:off x="868680" y="2240280"/>
+            <a:ext cx="3108960" cy="2560320"/>
+          </a:xfrm>
+          <a:prstGeom prst="rect">
+            <a:avLst/>
+          </a:prstGeom>
+          <a:noFill/>
+        </p:spPr>
+        <p:txBody>
+          <a:bodyPr wrap="square">
+            <a:spAutoFit/>
+          </a:bodyPr>
+          <a:lstStyle/>
+          <a:p>
+            <a:pPr algn="l"/>
+            <a:r>
+              <a:rPr sz="1200" b="0">
+                <a:solidFill>
+                  <a:srgbClr val="E5EDF7"/>
+                </a:solidFill>
+                <a:latin typeface="Aptos"/>
+              </a:rPr>
+              <a:t>Tenant-scoped FastAPI APIs, grounded RAG, OTP registration, dark-first auth UI, audit telemetry.</a:t>
+            </a:r>
+          </a:p>
+        </p:txBody>
+      </p:sp>
+      <p:sp>
+        <p:nvSpPr>
+          <p:cNvPr id="7" name="Rounded Rectangle 6"/>
+          <p:cNvSpPr/>
+          <p:nvPr/>
+        </p:nvSpPr>
+        <p:spPr>
+          <a:xfrm>
+            <a:off x="4389120" y="1645920"/>
+            <a:ext cx="3474720" cy="3291840"/>
+          </a:xfrm>
+          <a:prstGeom prst="roundRect">
+            <a:avLst/>
+          </a:prstGeom>
+          <a:solidFill>
+            <a:srgbClr val="111A2D"/>
+          </a:solidFill>
+          <a:ln>
+            <a:solidFill>
+              <a:srgbClr val="2D3A52"/>
+            </a:solidFill>
+          </a:ln>
+        </p:spPr>
+        <p:style>
+          <a:lnRef idx="1">
+            <a:schemeClr val="accent1"/>
+          </a:lnRef>
+          <a:fillRef idx="3">
+            <a:schemeClr val="accent1"/>
+          </a:fillRef>
+          <a:effectRef idx="2">
+            <a:schemeClr val="accent1"/>
+          </a:effectRef>
+          <a:fontRef idx="minor">
+            <a:schemeClr val="lt1"/>
+          </a:fontRef>
+        </p:style>
+        <p:txBody>
+          <a:bodyPr rtlCol="0" anchor="ctr"/>
+          <a:lstStyle/>
+          <a:p>
+            <a:pPr algn="ctr"/>
+          </a:p>
+        </p:txBody>
+      </p:sp>
+      <p:sp>
+        <p:nvSpPr>
+          <p:cNvPr id="8" name="TextBox 7"/>
+          <p:cNvSpPr txBox="1"/>
+          <p:nvPr/>
+        </p:nvSpPr>
+        <p:spPr>
+          <a:xfrm>
+            <a:off x="4572000" y="1810512"/>
+            <a:ext cx="3108960" cy="320040"/>
+          </a:xfrm>
+          <a:prstGeom prst="rect">
+            <a:avLst/>
+          </a:prstGeom>
+          <a:noFill/>
+        </p:spPr>
+        <p:txBody>
+          <a:bodyPr wrap="square">
+            <a:spAutoFit/>
+          </a:bodyPr>
+          <a:lstStyle/>
+          <a:p>
+            <a:pPr algn="l"/>
+            <a:r>
+              <a:rPr sz="1600" b="1">
+                <a:solidFill>
+                  <a:srgbClr val="2DD4BF"/>
+                </a:solidFill>
+                <a:latin typeface="Aptos"/>
+              </a:rPr>
+              <a:t>Next</a:t>
+            </a:r>
+          </a:p>
+        </p:txBody>
+      </p:sp>
+      <p:sp>
+        <p:nvSpPr>
+          <p:cNvPr id="9" name="TextBox 8"/>
+          <p:cNvSpPr txBox="1"/>
+          <p:nvPr/>
+        </p:nvSpPr>
+        <p:spPr>
+          <a:xfrm>
+            <a:off x="4572000" y="2240280"/>
+            <a:ext cx="3108960" cy="2560320"/>
+          </a:xfrm>
+          <a:prstGeom prst="rect">
+            <a:avLst/>
+          </a:prstGeom>
+          <a:noFill/>
+        </p:spPr>
+        <p:txBody>
+          <a:bodyPr wrap="square">
+            <a:spAutoFit/>
+          </a:bodyPr>
+          <a:lstStyle/>
+          <a:p>
+            <a:pPr algn="l"/>
+            <a:r>
+              <a:rPr sz="1200" b="0">
+                <a:solidFill>
+                  <a:srgbClr val="E5EDF7"/>
+                </a:solidFill>
+                <a:latin typeface="Aptos"/>
+              </a:rPr>
+              <a:t>Complete Telegram account linking and 120-second session enforcement on a shared bot service.</a:t>
+            </a:r>
+          </a:p>
+        </p:txBody>
+      </p:sp>
+      <p:sp>
+        <p:nvSpPr>
+          <p:cNvPr id="10" name="Rounded Rectangle 9"/>
+          <p:cNvSpPr/>
+          <p:nvPr/>
+        </p:nvSpPr>
+        <p:spPr>
+          <a:xfrm>
+            <a:off x="8092440" y="1645920"/>
+            <a:ext cx="3474720" cy="3291840"/>
+          </a:xfrm>
+          <a:prstGeom prst="roundRect">
+            <a:avLst/>
+          </a:prstGeom>
+          <a:solidFill>
+            <a:srgbClr val="111A2D"/>
+          </a:solidFill>
+          <a:ln>
+            <a:solidFill>
+              <a:srgbClr val="2D3A52"/>
+            </a:solidFill>
+          </a:ln>
+        </p:spPr>
+        <p:style>
+          <a:lnRef idx="1">
+            <a:schemeClr val="accent1"/>
+          </a:lnRef>
+          <a:fillRef idx="3">
+            <a:schemeClr val="accent1"/>
+          </a:fillRef>
+          <a:effectRef idx="2">
+            <a:schemeClr val="accent1"/>
+          </a:effectRef>
+          <a:fontRef idx="minor">
+            <a:schemeClr val="lt1"/>
+          </a:fontRef>
+        </p:style>
+        <p:txBody>
+          <a:bodyPr rtlCol="0" anchor="ctr"/>
+          <a:lstStyle/>
+          <a:p>
+            <a:pPr algn="ctr"/>
+          </a:p>
+        </p:txBody>
+      </p:sp>
+      <p:sp>
+        <p:nvSpPr>
+          <p:cNvPr id="11" name="TextBox 10"/>
+          <p:cNvSpPr txBox="1"/>
+          <p:nvPr/>
+        </p:nvSpPr>
+        <p:spPr>
+          <a:xfrm>
+            <a:off x="8275319" y="1810512"/>
+            <a:ext cx="3108960" cy="320040"/>
+          </a:xfrm>
+          <a:prstGeom prst="rect">
+            <a:avLst/>
+          </a:prstGeom>
+          <a:noFill/>
+        </p:spPr>
+        <p:txBody>
+          <a:bodyPr wrap="square">
+            <a:spAutoFit/>
+          </a:bodyPr>
+          <a:lstStyle/>
+          <a:p>
+            <a:pPr algn="l"/>
+            <a:r>
+              <a:rPr sz="1600" b="1">
+                <a:solidFill>
+                  <a:srgbClr val="2DD4BF"/>
+                </a:solidFill>
+                <a:latin typeface="Aptos"/>
+              </a:rPr>
+              <a:t>Future</a:t>
+            </a:r>
+          </a:p>
+        </p:txBody>
+      </p:sp>
+      <p:sp>
+        <p:nvSpPr>
+          <p:cNvPr id="12" name="TextBox 11"/>
+          <p:cNvSpPr txBox="1"/>
+          <p:nvPr/>
+        </p:nvSpPr>
+        <p:spPr>
+          <a:xfrm>
+            <a:off x="8275319" y="2240280"/>
+            <a:ext cx="3108960" cy="2560320"/>
+          </a:xfrm>
+          <a:prstGeom prst="rect">
+            <a:avLst/>
+          </a:prstGeom>
+          <a:noFill/>
+        </p:spPr>
+        <p:txBody>
+          <a:bodyPr wrap="square">
+            <a:spAutoFit/>
+          </a:bodyPr>
+          <a:lstStyle/>
+          <a:p>
+            <a:pPr algn="l"/>
+            <a:r>
+              <a:rPr sz="1200" b="0">
+                <a:solidFill>
+                  <a:srgbClr val="E5EDF7"/>
+                </a:solidFill>
+                <a:latin typeface="Aptos"/>
+              </a:rPr>
+              <a:t>Async workers, OCR, object storage, richer feedback/export, and managed deployment verification.</a:t>
+            </a:r>
+          </a:p>
+        </p:txBody>
+      </p:sp>
+      <p:sp>
+        <p:nvSpPr>
+          <p:cNvPr id="13" name="TextBox 12"/>
+          <p:cNvSpPr txBox="1"/>
+          <p:nvPr/>
+        </p:nvSpPr>
+        <p:spPr>
+          <a:xfrm>
+            <a:off x="914400" y="5715000"/>
+            <a:ext cx="10241280" cy="365760"/>
+          </a:xfrm>
+          <a:prstGeom prst="rect">
+            <a:avLst/>
+          </a:prstGeom>
+          <a:noFill/>
+        </p:spPr>
+        <p:txBody>
+          <a:bodyPr wrap="square">
+            <a:spAutoFit/>
+          </a:bodyPr>
+          <a:lstStyle/>
+          <a:p>
+            <a:pPr algn="ctr"/>
+            <a:r>
+              <a:rPr sz="1800" b="1">
+                <a:solidFill>
+                  <a:srgbClr val="2DD4BF"/>
+                </a:solidFill>
+                <a:latin typeface="Aptos"/>
+              </a:rPr>
+              <a:t>Build trust into the architecture, then make the demo visible.</a:t>
             </a:r>
           </a:p>
         </p:txBody>

</xml_diff>